<commit_message>
Merge section3_part2 into section3_block_diagrams as one section
Drop the redundant section-divider slide and append the internal
verification slides directly after the block diagrams, since this
was never meant to be a separate section.

Co-Authored-By: Claude Sonnet 4.6 <noreply@anthropic.com>
Claude-Session: https://claude.ai/code/session_01UcZX9gdfC56CAidpRSm7mN
</commit_message>
<xml_diff>
--- a/section3_block_diagrams.pptx
+++ b/section3_block_diagrams.pptx
@@ -15,9 +15,15 @@
     <p:sldId id="263" r:id="rId9"/>
     <p:sldId id="264" r:id="rId10"/>
     <p:sldId id="265" r:id="rId11"/>
+    <p:sldId id="266" r:id="rId12"/>
+    <p:sldId id="267" r:id="rId13"/>
+    <p:sldId id="268" r:id="rId14"/>
+    <p:sldId id="269" r:id="rId15"/>
+    <p:sldId id="270" r:id="rId16"/>
+    <p:sldId id="271" r:id="rId17"/>
   </p:sldIdLst>
   <p:notesMasterIdLst>
-    <p:notesMasterId r:id="rId12"/>
+    <p:notesMasterId r:id="rId18"/>
   </p:notesMasterIdLst>
   <p:sldSz cx="9144000" cy="5143500"/>
   <p:notesSz cx="5143500" cy="9144000"/>
@@ -623,6 +629,534 @@
             <a:fld id="{F7021451-1387-4CA6-816F-3879F97B5CBC}" type="slidenum">
               <a:rPr lang="en-US"/>
               <a:t>10</a:t>
+            </a:fld>
+            <a:endParaRPr lang="en-US"/>
+          </a:p>
+        </p:txBody>
+      </p:sp>
+    </p:spTree>
+    <p:extLst>
+      <p:ext uri="{BB962C8B-B14F-4D97-AF65-F5344CB8AC3E}">
+        <p14:creationId xmlns:p14="http://schemas.microsoft.com/office/powerpoint/2010/main" val="1024086991"/>
+      </p:ext>
+    </p:extLst>
+  </p:cSld>
+  <p:clrMapOvr>
+    <a:masterClrMapping/>
+  </p:clrMapOvr>
+</p:notes>
+</file>
+
+<file path=ppt/notesSlides/notesSlide11.xml><?xml version="1.0" encoding="utf-8"?>
+<p:notes xmlns:a="http://schemas.openxmlformats.org/drawingml/2006/main" xmlns:r="http://schemas.openxmlformats.org/officeDocument/2006/relationships" xmlns:p="http://schemas.openxmlformats.org/presentationml/2006/main">
+  <p:cSld>
+    <p:spTree>
+      <p:nvGrpSpPr>
+        <p:cNvPr id="1" name=""/>
+        <p:cNvGrpSpPr/>
+        <p:nvPr/>
+      </p:nvGrpSpPr>
+      <p:grpSpPr>
+        <a:xfrm>
+          <a:off x="0" y="0"/>
+          <a:ext cx="0" cy="0"/>
+          <a:chOff x="0" y="0"/>
+          <a:chExt cx="0" cy="0"/>
+        </a:xfrm>
+      </p:grpSpPr>
+      <p:sp>
+        <p:nvSpPr>
+          <p:cNvPr id="2" name="Slide Image Placeholder 1"/>
+          <p:cNvSpPr>
+            <a:spLocks noGrp="1" noRot="1" noChangeAspect="1"/>
+          </p:cNvSpPr>
+          <p:nvPr>
+            <p:ph type="sldImg"/>
+          </p:nvPr>
+        </p:nvSpPr>
+        <p:spPr/>
+      </p:sp>
+      <p:sp>
+        <p:nvSpPr>
+          <p:cNvPr id="3" name="Notes Placeholder 2"/>
+          <p:cNvSpPr>
+            <a:spLocks noGrp="1"/>
+          </p:cNvSpPr>
+          <p:nvPr>
+            <p:ph type="body" idx="1"/>
+          </p:nvPr>
+        </p:nvSpPr>
+        <p:spPr/>
+        <p:txBody>
+          <a:bodyPr/>
+          <a:lstStyle/>
+          <a:p>
+            <a:r>
+              <a:rPr lang="en-US" dirty="0"/>
+              <a:t/>
+            </a:r>
+            <a:endParaRPr lang="en-US" dirty="0"/>
+          </a:p>
+        </p:txBody>
+      </p:sp>
+      <p:sp>
+        <p:nvSpPr>
+          <p:cNvPr id="4" name="Slide Number Placeholder 3"/>
+          <p:cNvSpPr>
+            <a:spLocks noGrp="1"/>
+          </p:cNvSpPr>
+          <p:nvPr>
+            <p:ph type="sldNum" sz="quarter" idx="10"/>
+          </p:nvPr>
+        </p:nvSpPr>
+        <p:spPr/>
+        <p:txBody>
+          <a:bodyPr/>
+          <a:lstStyle/>
+          <a:p>
+            <a:fld id="{F7021451-1387-4CA6-816F-3879F97B5CBC}" type="slidenum">
+              <a:rPr lang="en-US"/>
+              <a:t>11</a:t>
+            </a:fld>
+            <a:endParaRPr lang="en-US"/>
+          </a:p>
+        </p:txBody>
+      </p:sp>
+    </p:spTree>
+    <p:extLst>
+      <p:ext uri="{BB962C8B-B14F-4D97-AF65-F5344CB8AC3E}">
+        <p14:creationId xmlns:p14="http://schemas.microsoft.com/office/powerpoint/2010/main" val="1024086991"/>
+      </p:ext>
+    </p:extLst>
+  </p:cSld>
+  <p:clrMapOvr>
+    <a:masterClrMapping/>
+  </p:clrMapOvr>
+</p:notes>
+</file>
+
+<file path=ppt/notesSlides/notesSlide12.xml><?xml version="1.0" encoding="utf-8"?>
+<p:notes xmlns:a="http://schemas.openxmlformats.org/drawingml/2006/main" xmlns:r="http://schemas.openxmlformats.org/officeDocument/2006/relationships" xmlns:p="http://schemas.openxmlformats.org/presentationml/2006/main">
+  <p:cSld>
+    <p:spTree>
+      <p:nvGrpSpPr>
+        <p:cNvPr id="1" name=""/>
+        <p:cNvGrpSpPr/>
+        <p:nvPr/>
+      </p:nvGrpSpPr>
+      <p:grpSpPr>
+        <a:xfrm>
+          <a:off x="0" y="0"/>
+          <a:ext cx="0" cy="0"/>
+          <a:chOff x="0" y="0"/>
+          <a:chExt cx="0" cy="0"/>
+        </a:xfrm>
+      </p:grpSpPr>
+      <p:sp>
+        <p:nvSpPr>
+          <p:cNvPr id="2" name="Slide Image Placeholder 1"/>
+          <p:cNvSpPr>
+            <a:spLocks noGrp="1" noRot="1" noChangeAspect="1"/>
+          </p:cNvSpPr>
+          <p:nvPr>
+            <p:ph type="sldImg"/>
+          </p:nvPr>
+        </p:nvSpPr>
+        <p:spPr/>
+      </p:sp>
+      <p:sp>
+        <p:nvSpPr>
+          <p:cNvPr id="3" name="Notes Placeholder 2"/>
+          <p:cNvSpPr>
+            <a:spLocks noGrp="1"/>
+          </p:cNvSpPr>
+          <p:nvPr>
+            <p:ph type="body" idx="1"/>
+          </p:nvPr>
+        </p:nvSpPr>
+        <p:spPr/>
+        <p:txBody>
+          <a:bodyPr/>
+          <a:lstStyle/>
+          <a:p>
+            <a:r>
+              <a:rPr lang="en-US" dirty="0"/>
+              <a:t/>
+            </a:r>
+            <a:endParaRPr lang="en-US" dirty="0"/>
+          </a:p>
+        </p:txBody>
+      </p:sp>
+      <p:sp>
+        <p:nvSpPr>
+          <p:cNvPr id="4" name="Slide Number Placeholder 3"/>
+          <p:cNvSpPr>
+            <a:spLocks noGrp="1"/>
+          </p:cNvSpPr>
+          <p:nvPr>
+            <p:ph type="sldNum" sz="quarter" idx="10"/>
+          </p:nvPr>
+        </p:nvSpPr>
+        <p:spPr/>
+        <p:txBody>
+          <a:bodyPr/>
+          <a:lstStyle/>
+          <a:p>
+            <a:fld id="{F7021451-1387-4CA6-816F-3879F97B5CBC}" type="slidenum">
+              <a:rPr lang="en-US"/>
+              <a:t>12</a:t>
+            </a:fld>
+            <a:endParaRPr lang="en-US"/>
+          </a:p>
+        </p:txBody>
+      </p:sp>
+    </p:spTree>
+    <p:extLst>
+      <p:ext uri="{BB962C8B-B14F-4D97-AF65-F5344CB8AC3E}">
+        <p14:creationId xmlns:p14="http://schemas.microsoft.com/office/powerpoint/2010/main" val="1024086991"/>
+      </p:ext>
+    </p:extLst>
+  </p:cSld>
+  <p:clrMapOvr>
+    <a:masterClrMapping/>
+  </p:clrMapOvr>
+</p:notes>
+</file>
+
+<file path=ppt/notesSlides/notesSlide13.xml><?xml version="1.0" encoding="utf-8"?>
+<p:notes xmlns:a="http://schemas.openxmlformats.org/drawingml/2006/main" xmlns:r="http://schemas.openxmlformats.org/officeDocument/2006/relationships" xmlns:p="http://schemas.openxmlformats.org/presentationml/2006/main">
+  <p:cSld>
+    <p:spTree>
+      <p:nvGrpSpPr>
+        <p:cNvPr id="1" name=""/>
+        <p:cNvGrpSpPr/>
+        <p:nvPr/>
+      </p:nvGrpSpPr>
+      <p:grpSpPr>
+        <a:xfrm>
+          <a:off x="0" y="0"/>
+          <a:ext cx="0" cy="0"/>
+          <a:chOff x="0" y="0"/>
+          <a:chExt cx="0" cy="0"/>
+        </a:xfrm>
+      </p:grpSpPr>
+      <p:sp>
+        <p:nvSpPr>
+          <p:cNvPr id="2" name="Slide Image Placeholder 1"/>
+          <p:cNvSpPr>
+            <a:spLocks noGrp="1" noRot="1" noChangeAspect="1"/>
+          </p:cNvSpPr>
+          <p:nvPr>
+            <p:ph type="sldImg"/>
+          </p:nvPr>
+        </p:nvSpPr>
+        <p:spPr/>
+      </p:sp>
+      <p:sp>
+        <p:nvSpPr>
+          <p:cNvPr id="3" name="Notes Placeholder 2"/>
+          <p:cNvSpPr>
+            <a:spLocks noGrp="1"/>
+          </p:cNvSpPr>
+          <p:nvPr>
+            <p:ph type="body" idx="1"/>
+          </p:nvPr>
+        </p:nvSpPr>
+        <p:spPr/>
+        <p:txBody>
+          <a:bodyPr/>
+          <a:lstStyle/>
+          <a:p>
+            <a:r>
+              <a:rPr lang="en-US" dirty="0"/>
+              <a:t/>
+            </a:r>
+            <a:endParaRPr lang="en-US" dirty="0"/>
+          </a:p>
+        </p:txBody>
+      </p:sp>
+      <p:sp>
+        <p:nvSpPr>
+          <p:cNvPr id="4" name="Slide Number Placeholder 3"/>
+          <p:cNvSpPr>
+            <a:spLocks noGrp="1"/>
+          </p:cNvSpPr>
+          <p:nvPr>
+            <p:ph type="sldNum" sz="quarter" idx="10"/>
+          </p:nvPr>
+        </p:nvSpPr>
+        <p:spPr/>
+        <p:txBody>
+          <a:bodyPr/>
+          <a:lstStyle/>
+          <a:p>
+            <a:fld id="{F7021451-1387-4CA6-816F-3879F97B5CBC}" type="slidenum">
+              <a:rPr lang="en-US"/>
+              <a:t>13</a:t>
+            </a:fld>
+            <a:endParaRPr lang="en-US"/>
+          </a:p>
+        </p:txBody>
+      </p:sp>
+    </p:spTree>
+    <p:extLst>
+      <p:ext uri="{BB962C8B-B14F-4D97-AF65-F5344CB8AC3E}">
+        <p14:creationId xmlns:p14="http://schemas.microsoft.com/office/powerpoint/2010/main" val="1024086991"/>
+      </p:ext>
+    </p:extLst>
+  </p:cSld>
+  <p:clrMapOvr>
+    <a:masterClrMapping/>
+  </p:clrMapOvr>
+</p:notes>
+</file>
+
+<file path=ppt/notesSlides/notesSlide14.xml><?xml version="1.0" encoding="utf-8"?>
+<p:notes xmlns:a="http://schemas.openxmlformats.org/drawingml/2006/main" xmlns:r="http://schemas.openxmlformats.org/officeDocument/2006/relationships" xmlns:p="http://schemas.openxmlformats.org/presentationml/2006/main">
+  <p:cSld>
+    <p:spTree>
+      <p:nvGrpSpPr>
+        <p:cNvPr id="1" name=""/>
+        <p:cNvGrpSpPr/>
+        <p:nvPr/>
+      </p:nvGrpSpPr>
+      <p:grpSpPr>
+        <a:xfrm>
+          <a:off x="0" y="0"/>
+          <a:ext cx="0" cy="0"/>
+          <a:chOff x="0" y="0"/>
+          <a:chExt cx="0" cy="0"/>
+        </a:xfrm>
+      </p:grpSpPr>
+      <p:sp>
+        <p:nvSpPr>
+          <p:cNvPr id="2" name="Slide Image Placeholder 1"/>
+          <p:cNvSpPr>
+            <a:spLocks noGrp="1" noRot="1" noChangeAspect="1"/>
+          </p:cNvSpPr>
+          <p:nvPr>
+            <p:ph type="sldImg"/>
+          </p:nvPr>
+        </p:nvSpPr>
+        <p:spPr/>
+      </p:sp>
+      <p:sp>
+        <p:nvSpPr>
+          <p:cNvPr id="3" name="Notes Placeholder 2"/>
+          <p:cNvSpPr>
+            <a:spLocks noGrp="1"/>
+          </p:cNvSpPr>
+          <p:nvPr>
+            <p:ph type="body" idx="1"/>
+          </p:nvPr>
+        </p:nvSpPr>
+        <p:spPr/>
+        <p:txBody>
+          <a:bodyPr/>
+          <a:lstStyle/>
+          <a:p>
+            <a:r>
+              <a:rPr lang="en-US" dirty="0"/>
+              <a:t/>
+            </a:r>
+            <a:endParaRPr lang="en-US" dirty="0"/>
+          </a:p>
+        </p:txBody>
+      </p:sp>
+      <p:sp>
+        <p:nvSpPr>
+          <p:cNvPr id="4" name="Slide Number Placeholder 3"/>
+          <p:cNvSpPr>
+            <a:spLocks noGrp="1"/>
+          </p:cNvSpPr>
+          <p:nvPr>
+            <p:ph type="sldNum" sz="quarter" idx="10"/>
+          </p:nvPr>
+        </p:nvSpPr>
+        <p:spPr/>
+        <p:txBody>
+          <a:bodyPr/>
+          <a:lstStyle/>
+          <a:p>
+            <a:fld id="{F7021451-1387-4CA6-816F-3879F97B5CBC}" type="slidenum">
+              <a:rPr lang="en-US"/>
+              <a:t>14</a:t>
+            </a:fld>
+            <a:endParaRPr lang="en-US"/>
+          </a:p>
+        </p:txBody>
+      </p:sp>
+    </p:spTree>
+    <p:extLst>
+      <p:ext uri="{BB962C8B-B14F-4D97-AF65-F5344CB8AC3E}">
+        <p14:creationId xmlns:p14="http://schemas.microsoft.com/office/powerpoint/2010/main" val="1024086991"/>
+      </p:ext>
+    </p:extLst>
+  </p:cSld>
+  <p:clrMapOvr>
+    <a:masterClrMapping/>
+  </p:clrMapOvr>
+</p:notes>
+</file>
+
+<file path=ppt/notesSlides/notesSlide15.xml><?xml version="1.0" encoding="utf-8"?>
+<p:notes xmlns:a="http://schemas.openxmlformats.org/drawingml/2006/main" xmlns:r="http://schemas.openxmlformats.org/officeDocument/2006/relationships" xmlns:p="http://schemas.openxmlformats.org/presentationml/2006/main">
+  <p:cSld>
+    <p:spTree>
+      <p:nvGrpSpPr>
+        <p:cNvPr id="1" name=""/>
+        <p:cNvGrpSpPr/>
+        <p:nvPr/>
+      </p:nvGrpSpPr>
+      <p:grpSpPr>
+        <a:xfrm>
+          <a:off x="0" y="0"/>
+          <a:ext cx="0" cy="0"/>
+          <a:chOff x="0" y="0"/>
+          <a:chExt cx="0" cy="0"/>
+        </a:xfrm>
+      </p:grpSpPr>
+      <p:sp>
+        <p:nvSpPr>
+          <p:cNvPr id="2" name="Slide Image Placeholder 1"/>
+          <p:cNvSpPr>
+            <a:spLocks noGrp="1" noRot="1" noChangeAspect="1"/>
+          </p:cNvSpPr>
+          <p:nvPr>
+            <p:ph type="sldImg"/>
+          </p:nvPr>
+        </p:nvSpPr>
+        <p:spPr/>
+      </p:sp>
+      <p:sp>
+        <p:nvSpPr>
+          <p:cNvPr id="3" name="Notes Placeholder 2"/>
+          <p:cNvSpPr>
+            <a:spLocks noGrp="1"/>
+          </p:cNvSpPr>
+          <p:nvPr>
+            <p:ph type="body" idx="1"/>
+          </p:nvPr>
+        </p:nvSpPr>
+        <p:spPr/>
+        <p:txBody>
+          <a:bodyPr/>
+          <a:lstStyle/>
+          <a:p>
+            <a:r>
+              <a:rPr lang="en-US" dirty="0"/>
+              <a:t/>
+            </a:r>
+            <a:endParaRPr lang="en-US" dirty="0"/>
+          </a:p>
+        </p:txBody>
+      </p:sp>
+      <p:sp>
+        <p:nvSpPr>
+          <p:cNvPr id="4" name="Slide Number Placeholder 3"/>
+          <p:cNvSpPr>
+            <a:spLocks noGrp="1"/>
+          </p:cNvSpPr>
+          <p:nvPr>
+            <p:ph type="sldNum" sz="quarter" idx="10"/>
+          </p:nvPr>
+        </p:nvSpPr>
+        <p:spPr/>
+        <p:txBody>
+          <a:bodyPr/>
+          <a:lstStyle/>
+          <a:p>
+            <a:fld id="{F7021451-1387-4CA6-816F-3879F97B5CBC}" type="slidenum">
+              <a:rPr lang="en-US"/>
+              <a:t>15</a:t>
+            </a:fld>
+            <a:endParaRPr lang="en-US"/>
+          </a:p>
+        </p:txBody>
+      </p:sp>
+    </p:spTree>
+    <p:extLst>
+      <p:ext uri="{BB962C8B-B14F-4D97-AF65-F5344CB8AC3E}">
+        <p14:creationId xmlns:p14="http://schemas.microsoft.com/office/powerpoint/2010/main" val="1024086991"/>
+      </p:ext>
+    </p:extLst>
+  </p:cSld>
+  <p:clrMapOvr>
+    <a:masterClrMapping/>
+  </p:clrMapOvr>
+</p:notes>
+</file>
+
+<file path=ppt/notesSlides/notesSlide16.xml><?xml version="1.0" encoding="utf-8"?>
+<p:notes xmlns:a="http://schemas.openxmlformats.org/drawingml/2006/main" xmlns:r="http://schemas.openxmlformats.org/officeDocument/2006/relationships" xmlns:p="http://schemas.openxmlformats.org/presentationml/2006/main">
+  <p:cSld>
+    <p:spTree>
+      <p:nvGrpSpPr>
+        <p:cNvPr id="1" name=""/>
+        <p:cNvGrpSpPr/>
+        <p:nvPr/>
+      </p:nvGrpSpPr>
+      <p:grpSpPr>
+        <a:xfrm>
+          <a:off x="0" y="0"/>
+          <a:ext cx="0" cy="0"/>
+          <a:chOff x="0" y="0"/>
+          <a:chExt cx="0" cy="0"/>
+        </a:xfrm>
+      </p:grpSpPr>
+      <p:sp>
+        <p:nvSpPr>
+          <p:cNvPr id="2" name="Slide Image Placeholder 1"/>
+          <p:cNvSpPr>
+            <a:spLocks noGrp="1" noRot="1" noChangeAspect="1"/>
+          </p:cNvSpPr>
+          <p:nvPr>
+            <p:ph type="sldImg"/>
+          </p:nvPr>
+        </p:nvSpPr>
+        <p:spPr/>
+      </p:sp>
+      <p:sp>
+        <p:nvSpPr>
+          <p:cNvPr id="3" name="Notes Placeholder 2"/>
+          <p:cNvSpPr>
+            <a:spLocks noGrp="1"/>
+          </p:cNvSpPr>
+          <p:nvPr>
+            <p:ph type="body" idx="1"/>
+          </p:nvPr>
+        </p:nvSpPr>
+        <p:spPr/>
+        <p:txBody>
+          <a:bodyPr/>
+          <a:lstStyle/>
+          <a:p>
+            <a:r>
+              <a:rPr lang="en-US" dirty="0"/>
+              <a:t/>
+            </a:r>
+            <a:endParaRPr lang="en-US" dirty="0"/>
+          </a:p>
+        </p:txBody>
+      </p:sp>
+      <p:sp>
+        <p:nvSpPr>
+          <p:cNvPr id="4" name="Slide Number Placeholder 3"/>
+          <p:cNvSpPr>
+            <a:spLocks noGrp="1"/>
+          </p:cNvSpPr>
+          <p:nvPr>
+            <p:ph type="sldNum" sz="quarter" idx="10"/>
+          </p:nvPr>
+        </p:nvSpPr>
+        <p:spPr/>
+        <p:txBody>
+          <a:bodyPr/>
+          <a:lstStyle/>
+          <a:p>
+            <a:fld id="{F7021451-1387-4CA6-816F-3879F97B5CBC}" type="slidenum">
+              <a:rPr lang="en-US"/>
+              <a:t>16</a:t>
             </a:fld>
             <a:endParaRPr lang="en-US"/>
           </a:p>
@@ -1991,6 +2525,2455 @@
 </p:sld>
 </file>
 
+<file path=ppt/slides/slide11.xml><?xml version="1.0" encoding="utf-8"?>
+<p:sld xmlns:a="http://schemas.openxmlformats.org/drawingml/2006/main" xmlns:r="http://schemas.openxmlformats.org/officeDocument/2006/relationships" xmlns:p="http://schemas.openxmlformats.org/presentationml/2006/main">
+  <p:cSld name="Slide 11">
+    <p:spTree>
+      <p:nvGrpSpPr>
+        <p:cNvPr id="1" name=""/>
+        <p:cNvGrpSpPr/>
+        <p:nvPr/>
+      </p:nvGrpSpPr>
+      <p:grpSpPr>
+        <a:xfrm>
+          <a:off x="0" y="0"/>
+          <a:ext cx="0" cy="0"/>
+          <a:chOff x="0" y="0"/>
+          <a:chExt cx="0" cy="0"/>
+        </a:xfrm>
+      </p:grpSpPr>
+      <p:sp>
+        <p:nvSpPr>
+          <p:cNvPr id="2" name="Text 0"/>
+          <p:cNvSpPr/>
+          <p:nvPr/>
+        </p:nvSpPr>
+        <p:spPr>
+          <a:xfrm>
+            <a:off x="548640" y="274320"/>
+            <a:ext cx="8046720" cy="777240"/>
+          </a:xfrm>
+          <a:prstGeom prst="rect">
+            <a:avLst/>
+          </a:prstGeom>
+          <a:noFill/>
+          <a:ln/>
+        </p:spPr>
+        <p:txBody>
+          <a:bodyPr wrap="square" lIns="0" tIns="0" rIns="0" bIns="0" rtlCol="0" anchor="ctr"/>
+          <a:lstStyle/>
+          <a:p>
+            <a:pPr indent="0" marL="0">
+              <a:buNone/>
+            </a:pPr>
+            <a:r>
+              <a:rPr lang="en-US" sz="3600" b="1" dirty="0">
+                <a:solidFill>
+                  <a:srgbClr val="111111"/>
+                </a:solidFill>
+                <a:latin typeface="Noto Sans CJK KR" pitchFamily="34" charset="0"/>
+                <a:ea typeface="Noto Sans CJK KR" pitchFamily="34" charset="-122"/>
+                <a:cs typeface="Noto Sans CJK KR" pitchFamily="34" charset="-120"/>
+              </a:rPr>
+              <a:t>Slave의 멀티 슬롯 시뮬레이션</a:t>
+            </a:r>
+            <a:endParaRPr lang="en-US" sz="3600" dirty="0"/>
+          </a:p>
+        </p:txBody>
+      </p:sp>
+      <p:sp>
+        <p:nvSpPr>
+          <p:cNvPr id="3" name="Text 1"/>
+          <p:cNvSpPr/>
+          <p:nvPr/>
+        </p:nvSpPr>
+        <p:spPr>
+          <a:xfrm>
+            <a:off x="548640" y="1234440"/>
+            <a:ext cx="8046720" cy="2971800"/>
+          </a:xfrm>
+          <a:prstGeom prst="rect">
+            <a:avLst/>
+          </a:prstGeom>
+          <a:noFill/>
+          <a:ln/>
+        </p:spPr>
+        <p:txBody>
+          <a:bodyPr wrap="square" rtlCol="0" anchor="t"/>
+          <a:lstStyle/>
+          <a:p>
+            <a:pPr marL="342900" indent="-342900">
+              <a:spcAft>
+                <a:spcPts val="1200"/>
+              </a:spcAft>
+              <a:buSzPct val="100000"/>
+              <a:buChar char="•"/>
+            </a:pPr>
+            <a:r>
+              <a:rPr lang="en-US" sz="2000" dirty="0">
+                <a:solidFill>
+                  <a:srgbClr val="222222"/>
+                </a:solidFill>
+                <a:latin typeface="Noto Sans CJK KR" pitchFamily="34" charset="0"/>
+                <a:ea typeface="Noto Sans CJK KR" pitchFamily="34" charset="-122"/>
+                <a:cs typeface="Noto Sans CJK KR" pitchFamily="34" charset="-120"/>
+              </a:rPr>
+              <a:t>통신 시연에서는 하나의 물리 시퀀서가 8개의 슬롯(슬롯 인덱스 0~7)을 순차 처리 — 슬롯 위치가 식별자 역할을 함</a:t>
+            </a:r>
+            <a:endParaRPr lang="en-US" sz="2000" dirty="0"/>
+          </a:p>
+          <a:p>
+            <a:pPr marL="342900" indent="-342900">
+              <a:spcAft>
+                <a:spcPts val="1200"/>
+              </a:spcAft>
+              <a:buSzPct val="100000"/>
+              <a:buChar char="•"/>
+            </a:pPr>
+            <a:r>
+              <a:rPr lang="en-US" sz="2000" dirty="0">
+                <a:solidFill>
+                  <a:srgbClr val="222222"/>
+                </a:solidFill>
+                <a:latin typeface="Noto Sans CJK KR" pitchFamily="34" charset="0"/>
+                <a:ea typeface="Noto Sans CJK KR" pitchFamily="34" charset="-122"/>
+                <a:cs typeface="Noto Sans CJK KR" pitchFamily="34" charset="-120"/>
+              </a:rPr>
+              <a:t>각 슬롯은 자신의 타임슬롯에서 자신의 payload를 전송 (슬롯별 절대 타겟 틱을 기준으로 순회)</a:t>
+            </a:r>
+            <a:endParaRPr lang="en-US" sz="2000" dirty="0"/>
+          </a:p>
+          <a:p>
+            <a:pPr marL="342900" indent="-342900">
+              <a:spcAft>
+                <a:spcPts val="1200"/>
+              </a:spcAft>
+              <a:buSzPct val="100000"/>
+              <a:buChar char="•"/>
+            </a:pPr>
+            <a:r>
+              <a:rPr lang="en-US" sz="2000" dirty="0">
+                <a:solidFill>
+                  <a:srgbClr val="222222"/>
+                </a:solidFill>
+                <a:latin typeface="Noto Sans CJK KR" pitchFamily="34" charset="0"/>
+                <a:ea typeface="Noto Sans CJK KR" pitchFamily="34" charset="-122"/>
+                <a:cs typeface="Noto Sans CJK KR" pitchFamily="34" charset="-120"/>
+              </a:rPr>
+              <a:t>슬롯 0~5는 AXI 레지스터, 슬롯 6~7은 외부 PL 버스에서 payload를 가져옴</a:t>
+            </a:r>
+            <a:endParaRPr lang="en-US" sz="2000" dirty="0"/>
+          </a:p>
+          <a:p>
+            <a:pPr marL="342900" indent="-342900">
+              <a:spcAft>
+                <a:spcPts val="1200"/>
+              </a:spcAft>
+              <a:buSzPct val="100000"/>
+              <a:buChar char="•"/>
+            </a:pPr>
+            <a:r>
+              <a:rPr lang="en-US" sz="2000" dirty="0">
+                <a:solidFill>
+                  <a:srgbClr val="222222"/>
+                </a:solidFill>
+                <a:latin typeface="Noto Sans CJK KR" pitchFamily="34" charset="0"/>
+                <a:ea typeface="Noto Sans CJK KR" pitchFamily="34" charset="-122"/>
+                <a:cs typeface="Noto Sans CJK KR" pitchFamily="34" charset="-120"/>
+              </a:rPr>
+              <a:t>시연에서는 버튼으로 payload 값을 바꾸고, 변경된 값이 Master에서 정확히 수신되는지 확인</a:t>
+            </a:r>
+            <a:endParaRPr lang="en-US" sz="2000" dirty="0"/>
+          </a:p>
+        </p:txBody>
+      </p:sp>
+      <p:sp>
+        <p:nvSpPr>
+          <p:cNvPr id="4" name="Text 2"/>
+          <p:cNvSpPr/>
+          <p:nvPr/>
+        </p:nvSpPr>
+        <p:spPr>
+          <a:xfrm>
+            <a:off x="8503920" y="4754880"/>
+            <a:ext cx="457200" cy="274320"/>
+          </a:xfrm>
+          <a:prstGeom prst="rect">
+            <a:avLst/>
+          </a:prstGeom>
+          <a:noFill/>
+          <a:ln/>
+        </p:spPr>
+        <p:txBody>
+          <a:bodyPr wrap="square" rtlCol="0" anchor="ctr"/>
+          <a:lstStyle/>
+          <a:p>
+            <a:pPr algn="r" indent="0" marL="0">
+              <a:buNone/>
+            </a:pPr>
+            <a:r>
+              <a:rPr lang="en-US" sz="1200" dirty="0">
+                <a:solidFill>
+                  <a:srgbClr val="999999"/>
+                </a:solidFill>
+                <a:latin typeface="Noto Sans CJK KR" pitchFamily="34" charset="0"/>
+                <a:ea typeface="Noto Sans CJK KR" pitchFamily="34" charset="-122"/>
+                <a:cs typeface="Noto Sans CJK KR" pitchFamily="34" charset="-120"/>
+              </a:rPr>
+              <a:t>11</a:t>
+            </a:r>
+            <a:endParaRPr lang="en-US" sz="1200" dirty="0"/>
+          </a:p>
+        </p:txBody>
+      </p:sp>
+    </p:spTree>
+  </p:cSld>
+  <p:clrMapOvr>
+    <a:masterClrMapping/>
+  </p:clrMapOvr>
+</p:sld>
+</file>
+
+<file path=ppt/slides/slide12.xml><?xml version="1.0" encoding="utf-8"?>
+<p:sld xmlns:a="http://schemas.openxmlformats.org/drawingml/2006/main" xmlns:r="http://schemas.openxmlformats.org/officeDocument/2006/relationships" xmlns:p="http://schemas.openxmlformats.org/presentationml/2006/main">
+  <p:cSld name="Slide 12">
+    <p:spTree>
+      <p:nvGrpSpPr>
+        <p:cNvPr id="1" name=""/>
+        <p:cNvGrpSpPr/>
+        <p:nvPr/>
+      </p:nvGrpSpPr>
+      <p:grpSpPr>
+        <a:xfrm>
+          <a:off x="0" y="0"/>
+          <a:ext cx="0" cy="0"/>
+          <a:chOff x="0" y="0"/>
+          <a:chExt cx="0" cy="0"/>
+        </a:xfrm>
+      </p:grpSpPr>
+      <p:sp>
+        <p:nvSpPr>
+          <p:cNvPr id="2" name="Text 0"/>
+          <p:cNvSpPr/>
+          <p:nvPr/>
+        </p:nvSpPr>
+        <p:spPr>
+          <a:xfrm>
+            <a:off x="548640" y="274320"/>
+            <a:ext cx="8046720" cy="777240"/>
+          </a:xfrm>
+          <a:prstGeom prst="rect">
+            <a:avLst/>
+          </a:prstGeom>
+          <a:noFill/>
+          <a:ln/>
+        </p:spPr>
+        <p:txBody>
+          <a:bodyPr wrap="square" lIns="0" tIns="0" rIns="0" bIns="0" rtlCol="0" anchor="ctr"/>
+          <a:lstStyle/>
+          <a:p>
+            <a:pPr indent="0" marL="0">
+              <a:buNone/>
+            </a:pPr>
+            <a:r>
+              <a:rPr lang="en-US" sz="3600" b="1" dirty="0">
+                <a:solidFill>
+                  <a:srgbClr val="111111"/>
+                </a:solidFill>
+                <a:latin typeface="Noto Sans CJK KR" pitchFamily="34" charset="0"/>
+                <a:ea typeface="Noto Sans CJK KR" pitchFamily="34" charset="-122"/>
+                <a:cs typeface="Noto Sans CJK KR" pitchFamily="34" charset="-120"/>
+              </a:rPr>
+              <a:t>Slave의 payload</a:t>
+            </a:r>
+            <a:endParaRPr lang="en-US" sz="3600" dirty="0"/>
+          </a:p>
+        </p:txBody>
+      </p:sp>
+      <p:sp>
+        <p:nvSpPr>
+          <p:cNvPr id="3" name="Text 1"/>
+          <p:cNvSpPr/>
+          <p:nvPr/>
+        </p:nvSpPr>
+        <p:spPr>
+          <a:xfrm>
+            <a:off x="548640" y="1188720"/>
+            <a:ext cx="8046720" cy="868680"/>
+          </a:xfrm>
+          <a:prstGeom prst="rect">
+            <a:avLst/>
+          </a:prstGeom>
+          <a:noFill/>
+          <a:ln/>
+        </p:spPr>
+        <p:txBody>
+          <a:bodyPr wrap="square" rtlCol="0" anchor="t"/>
+          <a:lstStyle/>
+          <a:p>
+            <a:pPr marL="342900" indent="-342900">
+              <a:spcAft>
+                <a:spcPts val="1000"/>
+              </a:spcAft>
+              <a:buSzPct val="100000"/>
+              <a:buChar char="•"/>
+            </a:pPr>
+            <a:r>
+              <a:rPr lang="en-US" sz="1800" dirty="0">
+                <a:solidFill>
+                  <a:srgbClr val="222222"/>
+                </a:solidFill>
+                <a:latin typeface="Noto Sans CJK KR" pitchFamily="34" charset="0"/>
+                <a:ea typeface="Noto Sans CJK KR" pitchFamily="34" charset="-122"/>
+                <a:cs typeface="Noto Sans CJK KR" pitchFamily="34" charset="-120"/>
+              </a:rPr>
+              <a:t>payload 레지스터는 리셋 시 0으로 초기화</a:t>
+            </a:r>
+            <a:endParaRPr lang="en-US" sz="1800" dirty="0"/>
+          </a:p>
+          <a:p>
+            <a:pPr marL="342900" indent="-342900">
+              <a:buSzPct val="100000"/>
+              <a:buChar char="•"/>
+            </a:pPr>
+            <a:r>
+              <a:rPr lang="en-US" sz="1800" dirty="0">
+                <a:solidFill>
+                  <a:srgbClr val="222222"/>
+                </a:solidFill>
+                <a:latin typeface="Noto Sans CJK KR" pitchFamily="34" charset="0"/>
+                <a:ea typeface="Noto Sans CJK KR" pitchFamily="34" charset="-122"/>
+                <a:cs typeface="Noto Sans CJK KR" pitchFamily="34" charset="-120"/>
+              </a:rPr>
+              <a:t>버튼을 누를 때마다 슬롯별로 정해진 값만큼 증가</a:t>
+            </a:r>
+            <a:endParaRPr lang="en-US" sz="1800" dirty="0"/>
+          </a:p>
+        </p:txBody>
+      </p:sp>
+      <p:graphicFrame>
+        <p:nvGraphicFramePr>
+          <p:cNvPr id="13" name="Table 0"/>
+          <p:cNvGraphicFramePr>
+            <a:graphicFrameLocks noGrp="1"/>
+          </p:cNvGraphicFramePr>
+          <p:nvPr>
+            <p:extLst>
+              <p:ext uri="{D42A27DB-BD31-4B8C-83A1-F6EECF244321}">
+                <p14:modId xmlns:p14="http://schemas.microsoft.com/office/powerpoint/2010/main" val="1579011935"/>
+              </p:ext>
+            </p:extLst>
+          </p:nvPr>
+        </p:nvGraphicFramePr>
+        <p:xfrm>
+          <a:off x="548640" y="2240280"/>
+          <a:ext cx="8046720" cy="914400"/>
+        </p:xfrm>
+        <a:graphic>
+          <a:graphicData uri="http://schemas.openxmlformats.org/drawingml/2006/table">
+            <a:tbl>
+              <a:tblPr/>
+              <a:tblGrid>
+                <a:gridCol w="894080"/>
+                <a:gridCol w="894080"/>
+                <a:gridCol w="894080"/>
+                <a:gridCol w="894080"/>
+                <a:gridCol w="894080"/>
+                <a:gridCol w="894080"/>
+                <a:gridCol w="894080"/>
+                <a:gridCol w="894080"/>
+                <a:gridCol w="894080"/>
+              </a:tblGrid>
+              <a:tr h="457200">
+                <a:tc>
+                  <a:txBody>
+                    <a:bodyPr/>
+                    <a:lstStyle/>
+                    <a:p>
+                      <a:pPr algn="ctr" indent="0" marL="0">
+                        <a:buNone/>
+                      </a:pPr>
+                      <a:r>
+                        <a:rPr lang="en-US" sz="1400" b="1" dirty="0">
+                          <a:solidFill>
+                            <a:srgbClr val="FFFFFF"/>
+                          </a:solidFill>
+                          <a:latin typeface="Noto Sans CJK KR" pitchFamily="34" charset="0"/>
+                          <a:ea typeface="Noto Sans CJK KR" pitchFamily="34" charset="-122"/>
+                          <a:cs typeface="Noto Sans CJK KR" pitchFamily="34" charset="-120"/>
+                        </a:rPr>
+                        <a:t>슬롯</a:t>
+                      </a:r>
+                      <a:endParaRPr lang="en-US" sz="1400" dirty="0">
+                        <a:latin typeface="Noto Sans CJK KR" charset="0"/>
+                        <a:ea typeface="Noto Sans CJK KR" charset="0"/>
+                        <a:cs typeface="Noto Sans CJK KR" charset="0"/>
+                      </a:endParaRPr>
+                    </a:p>
+                  </a:txBody>
+                  <a:tcPr marL="91440" marR="91440" marT="45720" marB="45720">
+                    <a:lnL w="6350" cap="flat" cmpd="sng" algn="ctr">
+                      <a:solidFill>
+                        <a:srgbClr val="CCCCCC"/>
+                      </a:solidFill>
+                      <a:prstDash val="solid"/>
+                      <a:round/>
+                      <a:headEnd type="none" w="med" len="med"/>
+                      <a:tailEnd type="none" w="med" len="med"/>
+                    </a:lnL>
+                    <a:lnR w="6350" cap="flat" cmpd="sng" algn="ctr">
+                      <a:solidFill>
+                        <a:srgbClr val="CCCCCC"/>
+                      </a:solidFill>
+                      <a:prstDash val="solid"/>
+                      <a:round/>
+                      <a:headEnd type="none" w="med" len="med"/>
+                      <a:tailEnd type="none" w="med" len="med"/>
+                    </a:lnR>
+                    <a:lnT w="6350" cap="flat" cmpd="sng" algn="ctr">
+                      <a:solidFill>
+                        <a:srgbClr val="CCCCCC"/>
+                      </a:solidFill>
+                      <a:prstDash val="solid"/>
+                      <a:round/>
+                      <a:headEnd type="none" w="med" len="med"/>
+                      <a:tailEnd type="none" w="med" len="med"/>
+                    </a:lnT>
+                    <a:lnB w="6350" cap="flat" cmpd="sng" algn="ctr">
+                      <a:solidFill>
+                        <a:srgbClr val="CCCCCC"/>
+                      </a:solidFill>
+                      <a:prstDash val="solid"/>
+                      <a:round/>
+                      <a:headEnd type="none" w="med" len="med"/>
+                      <a:tailEnd type="none" w="med" len="med"/>
+                    </a:lnB>
+                    <a:solidFill>
+                      <a:srgbClr val="2D2D2D"/>
+                    </a:solidFill>
+                  </a:tcPr>
+                </a:tc>
+                <a:tc>
+                  <a:txBody>
+                    <a:bodyPr/>
+                    <a:lstStyle/>
+                    <a:p>
+                      <a:pPr algn="ctr" indent="0" marL="0">
+                        <a:buNone/>
+                      </a:pPr>
+                      <a:r>
+                        <a:rPr lang="en-US" sz="1400" b="1" dirty="0">
+                          <a:solidFill>
+                            <a:srgbClr val="FFFFFF"/>
+                          </a:solidFill>
+                          <a:latin typeface="Noto Sans CJK KR" pitchFamily="34" charset="0"/>
+                          <a:ea typeface="Noto Sans CJK KR" pitchFamily="34" charset="-122"/>
+                          <a:cs typeface="Noto Sans CJK KR" pitchFamily="34" charset="-120"/>
+                        </a:rPr>
+                        <a:t>0</a:t>
+                      </a:r>
+                      <a:endParaRPr lang="en-US" sz="1400" dirty="0">
+                        <a:latin typeface="Noto Sans CJK KR" charset="0"/>
+                        <a:ea typeface="Noto Sans CJK KR" charset="0"/>
+                        <a:cs typeface="Noto Sans CJK KR" charset="0"/>
+                      </a:endParaRPr>
+                    </a:p>
+                  </a:txBody>
+                  <a:tcPr marL="91440" marR="91440" marT="45720" marB="45720">
+                    <a:lnL w="6350" cap="flat" cmpd="sng" algn="ctr">
+                      <a:solidFill>
+                        <a:srgbClr val="CCCCCC"/>
+                      </a:solidFill>
+                      <a:prstDash val="solid"/>
+                      <a:round/>
+                      <a:headEnd type="none" w="med" len="med"/>
+                      <a:tailEnd type="none" w="med" len="med"/>
+                    </a:lnL>
+                    <a:lnR w="6350" cap="flat" cmpd="sng" algn="ctr">
+                      <a:solidFill>
+                        <a:srgbClr val="CCCCCC"/>
+                      </a:solidFill>
+                      <a:prstDash val="solid"/>
+                      <a:round/>
+                      <a:headEnd type="none" w="med" len="med"/>
+                      <a:tailEnd type="none" w="med" len="med"/>
+                    </a:lnR>
+                    <a:lnT w="6350" cap="flat" cmpd="sng" algn="ctr">
+                      <a:solidFill>
+                        <a:srgbClr val="CCCCCC"/>
+                      </a:solidFill>
+                      <a:prstDash val="solid"/>
+                      <a:round/>
+                      <a:headEnd type="none" w="med" len="med"/>
+                      <a:tailEnd type="none" w="med" len="med"/>
+                    </a:lnT>
+                    <a:lnB w="6350" cap="flat" cmpd="sng" algn="ctr">
+                      <a:solidFill>
+                        <a:srgbClr val="CCCCCC"/>
+                      </a:solidFill>
+                      <a:prstDash val="solid"/>
+                      <a:round/>
+                      <a:headEnd type="none" w="med" len="med"/>
+                      <a:tailEnd type="none" w="med" len="med"/>
+                    </a:lnB>
+                    <a:solidFill>
+                      <a:srgbClr val="2D2D2D"/>
+                    </a:solidFill>
+                  </a:tcPr>
+                </a:tc>
+                <a:tc>
+                  <a:txBody>
+                    <a:bodyPr/>
+                    <a:lstStyle/>
+                    <a:p>
+                      <a:pPr algn="ctr" indent="0" marL="0">
+                        <a:buNone/>
+                      </a:pPr>
+                      <a:r>
+                        <a:rPr lang="en-US" sz="1400" b="1" dirty="0">
+                          <a:solidFill>
+                            <a:srgbClr val="FFFFFF"/>
+                          </a:solidFill>
+                          <a:latin typeface="Noto Sans CJK KR" pitchFamily="34" charset="0"/>
+                          <a:ea typeface="Noto Sans CJK KR" pitchFamily="34" charset="-122"/>
+                          <a:cs typeface="Noto Sans CJK KR" pitchFamily="34" charset="-120"/>
+                        </a:rPr>
+                        <a:t>1</a:t>
+                      </a:r>
+                      <a:endParaRPr lang="en-US" sz="1400" dirty="0">
+                        <a:latin typeface="Noto Sans CJK KR" charset="0"/>
+                        <a:ea typeface="Noto Sans CJK KR" charset="0"/>
+                        <a:cs typeface="Noto Sans CJK KR" charset="0"/>
+                      </a:endParaRPr>
+                    </a:p>
+                  </a:txBody>
+                  <a:tcPr marL="91440" marR="91440" marT="45720" marB="45720">
+                    <a:lnL w="6350" cap="flat" cmpd="sng" algn="ctr">
+                      <a:solidFill>
+                        <a:srgbClr val="CCCCCC"/>
+                      </a:solidFill>
+                      <a:prstDash val="solid"/>
+                      <a:round/>
+                      <a:headEnd type="none" w="med" len="med"/>
+                      <a:tailEnd type="none" w="med" len="med"/>
+                    </a:lnL>
+                    <a:lnR w="6350" cap="flat" cmpd="sng" algn="ctr">
+                      <a:solidFill>
+                        <a:srgbClr val="CCCCCC"/>
+                      </a:solidFill>
+                      <a:prstDash val="solid"/>
+                      <a:round/>
+                      <a:headEnd type="none" w="med" len="med"/>
+                      <a:tailEnd type="none" w="med" len="med"/>
+                    </a:lnR>
+                    <a:lnT w="6350" cap="flat" cmpd="sng" algn="ctr">
+                      <a:solidFill>
+                        <a:srgbClr val="CCCCCC"/>
+                      </a:solidFill>
+                      <a:prstDash val="solid"/>
+                      <a:round/>
+                      <a:headEnd type="none" w="med" len="med"/>
+                      <a:tailEnd type="none" w="med" len="med"/>
+                    </a:lnT>
+                    <a:lnB w="6350" cap="flat" cmpd="sng" algn="ctr">
+                      <a:solidFill>
+                        <a:srgbClr val="CCCCCC"/>
+                      </a:solidFill>
+                      <a:prstDash val="solid"/>
+                      <a:round/>
+                      <a:headEnd type="none" w="med" len="med"/>
+                      <a:tailEnd type="none" w="med" len="med"/>
+                    </a:lnB>
+                    <a:solidFill>
+                      <a:srgbClr val="2D2D2D"/>
+                    </a:solidFill>
+                  </a:tcPr>
+                </a:tc>
+                <a:tc>
+                  <a:txBody>
+                    <a:bodyPr/>
+                    <a:lstStyle/>
+                    <a:p>
+                      <a:pPr algn="ctr" indent="0" marL="0">
+                        <a:buNone/>
+                      </a:pPr>
+                      <a:r>
+                        <a:rPr lang="en-US" sz="1400" b="1" dirty="0">
+                          <a:solidFill>
+                            <a:srgbClr val="FFFFFF"/>
+                          </a:solidFill>
+                          <a:latin typeface="Noto Sans CJK KR" pitchFamily="34" charset="0"/>
+                          <a:ea typeface="Noto Sans CJK KR" pitchFamily="34" charset="-122"/>
+                          <a:cs typeface="Noto Sans CJK KR" pitchFamily="34" charset="-120"/>
+                        </a:rPr>
+                        <a:t>2</a:t>
+                      </a:r>
+                      <a:endParaRPr lang="en-US" sz="1400" dirty="0">
+                        <a:latin typeface="Noto Sans CJK KR" charset="0"/>
+                        <a:ea typeface="Noto Sans CJK KR" charset="0"/>
+                        <a:cs typeface="Noto Sans CJK KR" charset="0"/>
+                      </a:endParaRPr>
+                    </a:p>
+                  </a:txBody>
+                  <a:tcPr marL="91440" marR="91440" marT="45720" marB="45720">
+                    <a:lnL w="6350" cap="flat" cmpd="sng" algn="ctr">
+                      <a:solidFill>
+                        <a:srgbClr val="CCCCCC"/>
+                      </a:solidFill>
+                      <a:prstDash val="solid"/>
+                      <a:round/>
+                      <a:headEnd type="none" w="med" len="med"/>
+                      <a:tailEnd type="none" w="med" len="med"/>
+                    </a:lnL>
+                    <a:lnR w="6350" cap="flat" cmpd="sng" algn="ctr">
+                      <a:solidFill>
+                        <a:srgbClr val="CCCCCC"/>
+                      </a:solidFill>
+                      <a:prstDash val="solid"/>
+                      <a:round/>
+                      <a:headEnd type="none" w="med" len="med"/>
+                      <a:tailEnd type="none" w="med" len="med"/>
+                    </a:lnR>
+                    <a:lnT w="6350" cap="flat" cmpd="sng" algn="ctr">
+                      <a:solidFill>
+                        <a:srgbClr val="CCCCCC"/>
+                      </a:solidFill>
+                      <a:prstDash val="solid"/>
+                      <a:round/>
+                      <a:headEnd type="none" w="med" len="med"/>
+                      <a:tailEnd type="none" w="med" len="med"/>
+                    </a:lnT>
+                    <a:lnB w="6350" cap="flat" cmpd="sng" algn="ctr">
+                      <a:solidFill>
+                        <a:srgbClr val="CCCCCC"/>
+                      </a:solidFill>
+                      <a:prstDash val="solid"/>
+                      <a:round/>
+                      <a:headEnd type="none" w="med" len="med"/>
+                      <a:tailEnd type="none" w="med" len="med"/>
+                    </a:lnB>
+                    <a:solidFill>
+                      <a:srgbClr val="2D2D2D"/>
+                    </a:solidFill>
+                  </a:tcPr>
+                </a:tc>
+                <a:tc>
+                  <a:txBody>
+                    <a:bodyPr/>
+                    <a:lstStyle/>
+                    <a:p>
+                      <a:pPr algn="ctr" indent="0" marL="0">
+                        <a:buNone/>
+                      </a:pPr>
+                      <a:r>
+                        <a:rPr lang="en-US" sz="1400" b="1" dirty="0">
+                          <a:solidFill>
+                            <a:srgbClr val="FFFFFF"/>
+                          </a:solidFill>
+                          <a:latin typeface="Noto Sans CJK KR" pitchFamily="34" charset="0"/>
+                          <a:ea typeface="Noto Sans CJK KR" pitchFamily="34" charset="-122"/>
+                          <a:cs typeface="Noto Sans CJK KR" pitchFamily="34" charset="-120"/>
+                        </a:rPr>
+                        <a:t>3</a:t>
+                      </a:r>
+                      <a:endParaRPr lang="en-US" sz="1400" dirty="0">
+                        <a:latin typeface="Noto Sans CJK KR" charset="0"/>
+                        <a:ea typeface="Noto Sans CJK KR" charset="0"/>
+                        <a:cs typeface="Noto Sans CJK KR" charset="0"/>
+                      </a:endParaRPr>
+                    </a:p>
+                  </a:txBody>
+                  <a:tcPr marL="91440" marR="91440" marT="45720" marB="45720">
+                    <a:lnL w="6350" cap="flat" cmpd="sng" algn="ctr">
+                      <a:solidFill>
+                        <a:srgbClr val="CCCCCC"/>
+                      </a:solidFill>
+                      <a:prstDash val="solid"/>
+                      <a:round/>
+                      <a:headEnd type="none" w="med" len="med"/>
+                      <a:tailEnd type="none" w="med" len="med"/>
+                    </a:lnL>
+                    <a:lnR w="6350" cap="flat" cmpd="sng" algn="ctr">
+                      <a:solidFill>
+                        <a:srgbClr val="CCCCCC"/>
+                      </a:solidFill>
+                      <a:prstDash val="solid"/>
+                      <a:round/>
+                      <a:headEnd type="none" w="med" len="med"/>
+                      <a:tailEnd type="none" w="med" len="med"/>
+                    </a:lnR>
+                    <a:lnT w="6350" cap="flat" cmpd="sng" algn="ctr">
+                      <a:solidFill>
+                        <a:srgbClr val="CCCCCC"/>
+                      </a:solidFill>
+                      <a:prstDash val="solid"/>
+                      <a:round/>
+                      <a:headEnd type="none" w="med" len="med"/>
+                      <a:tailEnd type="none" w="med" len="med"/>
+                    </a:lnT>
+                    <a:lnB w="6350" cap="flat" cmpd="sng" algn="ctr">
+                      <a:solidFill>
+                        <a:srgbClr val="CCCCCC"/>
+                      </a:solidFill>
+                      <a:prstDash val="solid"/>
+                      <a:round/>
+                      <a:headEnd type="none" w="med" len="med"/>
+                      <a:tailEnd type="none" w="med" len="med"/>
+                    </a:lnB>
+                    <a:solidFill>
+                      <a:srgbClr val="2D2D2D"/>
+                    </a:solidFill>
+                  </a:tcPr>
+                </a:tc>
+                <a:tc>
+                  <a:txBody>
+                    <a:bodyPr/>
+                    <a:lstStyle/>
+                    <a:p>
+                      <a:pPr algn="ctr" indent="0" marL="0">
+                        <a:buNone/>
+                      </a:pPr>
+                      <a:r>
+                        <a:rPr lang="en-US" sz="1400" b="1" dirty="0">
+                          <a:solidFill>
+                            <a:srgbClr val="FFFFFF"/>
+                          </a:solidFill>
+                          <a:latin typeface="Noto Sans CJK KR" pitchFamily="34" charset="0"/>
+                          <a:ea typeface="Noto Sans CJK KR" pitchFamily="34" charset="-122"/>
+                          <a:cs typeface="Noto Sans CJK KR" pitchFamily="34" charset="-120"/>
+                        </a:rPr>
+                        <a:t>4</a:t>
+                      </a:r>
+                      <a:endParaRPr lang="en-US" sz="1400" dirty="0">
+                        <a:latin typeface="Noto Sans CJK KR" charset="0"/>
+                        <a:ea typeface="Noto Sans CJK KR" charset="0"/>
+                        <a:cs typeface="Noto Sans CJK KR" charset="0"/>
+                      </a:endParaRPr>
+                    </a:p>
+                  </a:txBody>
+                  <a:tcPr marL="91440" marR="91440" marT="45720" marB="45720">
+                    <a:lnL w="6350" cap="flat" cmpd="sng" algn="ctr">
+                      <a:solidFill>
+                        <a:srgbClr val="CCCCCC"/>
+                      </a:solidFill>
+                      <a:prstDash val="solid"/>
+                      <a:round/>
+                      <a:headEnd type="none" w="med" len="med"/>
+                      <a:tailEnd type="none" w="med" len="med"/>
+                    </a:lnL>
+                    <a:lnR w="6350" cap="flat" cmpd="sng" algn="ctr">
+                      <a:solidFill>
+                        <a:srgbClr val="CCCCCC"/>
+                      </a:solidFill>
+                      <a:prstDash val="solid"/>
+                      <a:round/>
+                      <a:headEnd type="none" w="med" len="med"/>
+                      <a:tailEnd type="none" w="med" len="med"/>
+                    </a:lnR>
+                    <a:lnT w="6350" cap="flat" cmpd="sng" algn="ctr">
+                      <a:solidFill>
+                        <a:srgbClr val="CCCCCC"/>
+                      </a:solidFill>
+                      <a:prstDash val="solid"/>
+                      <a:round/>
+                      <a:headEnd type="none" w="med" len="med"/>
+                      <a:tailEnd type="none" w="med" len="med"/>
+                    </a:lnT>
+                    <a:lnB w="6350" cap="flat" cmpd="sng" algn="ctr">
+                      <a:solidFill>
+                        <a:srgbClr val="CCCCCC"/>
+                      </a:solidFill>
+                      <a:prstDash val="solid"/>
+                      <a:round/>
+                      <a:headEnd type="none" w="med" len="med"/>
+                      <a:tailEnd type="none" w="med" len="med"/>
+                    </a:lnB>
+                    <a:solidFill>
+                      <a:srgbClr val="2D2D2D"/>
+                    </a:solidFill>
+                  </a:tcPr>
+                </a:tc>
+                <a:tc>
+                  <a:txBody>
+                    <a:bodyPr/>
+                    <a:lstStyle/>
+                    <a:p>
+                      <a:pPr algn="ctr" indent="0" marL="0">
+                        <a:buNone/>
+                      </a:pPr>
+                      <a:r>
+                        <a:rPr lang="en-US" sz="1400" b="1" dirty="0">
+                          <a:solidFill>
+                            <a:srgbClr val="FFFFFF"/>
+                          </a:solidFill>
+                          <a:latin typeface="Noto Sans CJK KR" pitchFamily="34" charset="0"/>
+                          <a:ea typeface="Noto Sans CJK KR" pitchFamily="34" charset="-122"/>
+                          <a:cs typeface="Noto Sans CJK KR" pitchFamily="34" charset="-120"/>
+                        </a:rPr>
+                        <a:t>5</a:t>
+                      </a:r>
+                      <a:endParaRPr lang="en-US" sz="1400" dirty="0">
+                        <a:latin typeface="Noto Sans CJK KR" charset="0"/>
+                        <a:ea typeface="Noto Sans CJK KR" charset="0"/>
+                        <a:cs typeface="Noto Sans CJK KR" charset="0"/>
+                      </a:endParaRPr>
+                    </a:p>
+                  </a:txBody>
+                  <a:tcPr marL="91440" marR="91440" marT="45720" marB="45720">
+                    <a:lnL w="6350" cap="flat" cmpd="sng" algn="ctr">
+                      <a:solidFill>
+                        <a:srgbClr val="CCCCCC"/>
+                      </a:solidFill>
+                      <a:prstDash val="solid"/>
+                      <a:round/>
+                      <a:headEnd type="none" w="med" len="med"/>
+                      <a:tailEnd type="none" w="med" len="med"/>
+                    </a:lnL>
+                    <a:lnR w="6350" cap="flat" cmpd="sng" algn="ctr">
+                      <a:solidFill>
+                        <a:srgbClr val="CCCCCC"/>
+                      </a:solidFill>
+                      <a:prstDash val="solid"/>
+                      <a:round/>
+                      <a:headEnd type="none" w="med" len="med"/>
+                      <a:tailEnd type="none" w="med" len="med"/>
+                    </a:lnR>
+                    <a:lnT w="6350" cap="flat" cmpd="sng" algn="ctr">
+                      <a:solidFill>
+                        <a:srgbClr val="CCCCCC"/>
+                      </a:solidFill>
+                      <a:prstDash val="solid"/>
+                      <a:round/>
+                      <a:headEnd type="none" w="med" len="med"/>
+                      <a:tailEnd type="none" w="med" len="med"/>
+                    </a:lnT>
+                    <a:lnB w="6350" cap="flat" cmpd="sng" algn="ctr">
+                      <a:solidFill>
+                        <a:srgbClr val="CCCCCC"/>
+                      </a:solidFill>
+                      <a:prstDash val="solid"/>
+                      <a:round/>
+                      <a:headEnd type="none" w="med" len="med"/>
+                      <a:tailEnd type="none" w="med" len="med"/>
+                    </a:lnB>
+                    <a:solidFill>
+                      <a:srgbClr val="2D2D2D"/>
+                    </a:solidFill>
+                  </a:tcPr>
+                </a:tc>
+                <a:tc>
+                  <a:txBody>
+                    <a:bodyPr/>
+                    <a:lstStyle/>
+                    <a:p>
+                      <a:pPr algn="ctr" indent="0" marL="0">
+                        <a:buNone/>
+                      </a:pPr>
+                      <a:r>
+                        <a:rPr lang="en-US" sz="1400" b="1" dirty="0">
+                          <a:solidFill>
+                            <a:srgbClr val="FFFFFF"/>
+                          </a:solidFill>
+                          <a:latin typeface="Noto Sans CJK KR" pitchFamily="34" charset="0"/>
+                          <a:ea typeface="Noto Sans CJK KR" pitchFamily="34" charset="-122"/>
+                          <a:cs typeface="Noto Sans CJK KR" pitchFamily="34" charset="-120"/>
+                        </a:rPr>
+                        <a:t>6</a:t>
+                      </a:r>
+                      <a:endParaRPr lang="en-US" sz="1400" dirty="0">
+                        <a:latin typeface="Noto Sans CJK KR" charset="0"/>
+                        <a:ea typeface="Noto Sans CJK KR" charset="0"/>
+                        <a:cs typeface="Noto Sans CJK KR" charset="0"/>
+                      </a:endParaRPr>
+                    </a:p>
+                  </a:txBody>
+                  <a:tcPr marL="91440" marR="91440" marT="45720" marB="45720">
+                    <a:lnL w="6350" cap="flat" cmpd="sng" algn="ctr">
+                      <a:solidFill>
+                        <a:srgbClr val="CCCCCC"/>
+                      </a:solidFill>
+                      <a:prstDash val="solid"/>
+                      <a:round/>
+                      <a:headEnd type="none" w="med" len="med"/>
+                      <a:tailEnd type="none" w="med" len="med"/>
+                    </a:lnL>
+                    <a:lnR w="6350" cap="flat" cmpd="sng" algn="ctr">
+                      <a:solidFill>
+                        <a:srgbClr val="CCCCCC"/>
+                      </a:solidFill>
+                      <a:prstDash val="solid"/>
+                      <a:round/>
+                      <a:headEnd type="none" w="med" len="med"/>
+                      <a:tailEnd type="none" w="med" len="med"/>
+                    </a:lnR>
+                    <a:lnT w="6350" cap="flat" cmpd="sng" algn="ctr">
+                      <a:solidFill>
+                        <a:srgbClr val="CCCCCC"/>
+                      </a:solidFill>
+                      <a:prstDash val="solid"/>
+                      <a:round/>
+                      <a:headEnd type="none" w="med" len="med"/>
+                      <a:tailEnd type="none" w="med" len="med"/>
+                    </a:lnT>
+                    <a:lnB w="6350" cap="flat" cmpd="sng" algn="ctr">
+                      <a:solidFill>
+                        <a:srgbClr val="CCCCCC"/>
+                      </a:solidFill>
+                      <a:prstDash val="solid"/>
+                      <a:round/>
+                      <a:headEnd type="none" w="med" len="med"/>
+                      <a:tailEnd type="none" w="med" len="med"/>
+                    </a:lnB>
+                    <a:solidFill>
+                      <a:srgbClr val="2D2D2D"/>
+                    </a:solidFill>
+                  </a:tcPr>
+                </a:tc>
+                <a:tc>
+                  <a:txBody>
+                    <a:bodyPr/>
+                    <a:lstStyle/>
+                    <a:p>
+                      <a:pPr algn="ctr" indent="0" marL="0">
+                        <a:buNone/>
+                      </a:pPr>
+                      <a:r>
+                        <a:rPr lang="en-US" sz="1400" b="1" dirty="0">
+                          <a:solidFill>
+                            <a:srgbClr val="FFFFFF"/>
+                          </a:solidFill>
+                          <a:latin typeface="Noto Sans CJK KR" pitchFamily="34" charset="0"/>
+                          <a:ea typeface="Noto Sans CJK KR" pitchFamily="34" charset="-122"/>
+                          <a:cs typeface="Noto Sans CJK KR" pitchFamily="34" charset="-120"/>
+                        </a:rPr>
+                        <a:t>7</a:t>
+                      </a:r>
+                      <a:endParaRPr lang="en-US" sz="1400" dirty="0">
+                        <a:latin typeface="Noto Sans CJK KR" charset="0"/>
+                        <a:ea typeface="Noto Sans CJK KR" charset="0"/>
+                        <a:cs typeface="Noto Sans CJK KR" charset="0"/>
+                      </a:endParaRPr>
+                    </a:p>
+                  </a:txBody>
+                  <a:tcPr marL="91440" marR="91440" marT="45720" marB="45720">
+                    <a:lnL w="6350" cap="flat" cmpd="sng" algn="ctr">
+                      <a:solidFill>
+                        <a:srgbClr val="CCCCCC"/>
+                      </a:solidFill>
+                      <a:prstDash val="solid"/>
+                      <a:round/>
+                      <a:headEnd type="none" w="med" len="med"/>
+                      <a:tailEnd type="none" w="med" len="med"/>
+                    </a:lnL>
+                    <a:lnR w="6350" cap="flat" cmpd="sng" algn="ctr">
+                      <a:solidFill>
+                        <a:srgbClr val="CCCCCC"/>
+                      </a:solidFill>
+                      <a:prstDash val="solid"/>
+                      <a:round/>
+                      <a:headEnd type="none" w="med" len="med"/>
+                      <a:tailEnd type="none" w="med" len="med"/>
+                    </a:lnR>
+                    <a:lnT w="6350" cap="flat" cmpd="sng" algn="ctr">
+                      <a:solidFill>
+                        <a:srgbClr val="CCCCCC"/>
+                      </a:solidFill>
+                      <a:prstDash val="solid"/>
+                      <a:round/>
+                      <a:headEnd type="none" w="med" len="med"/>
+                      <a:tailEnd type="none" w="med" len="med"/>
+                    </a:lnT>
+                    <a:lnB w="6350" cap="flat" cmpd="sng" algn="ctr">
+                      <a:solidFill>
+                        <a:srgbClr val="CCCCCC"/>
+                      </a:solidFill>
+                      <a:prstDash val="solid"/>
+                      <a:round/>
+                      <a:headEnd type="none" w="med" len="med"/>
+                      <a:tailEnd type="none" w="med" len="med"/>
+                    </a:lnB>
+                    <a:solidFill>
+                      <a:srgbClr val="2D2D2D"/>
+                    </a:solidFill>
+                  </a:tcPr>
+                </a:tc>
+              </a:tr>
+              <a:tr h="457200">
+                <a:tc>
+                  <a:txBody>
+                    <a:bodyPr/>
+                    <a:lstStyle/>
+                    <a:p>
+                      <a:pPr algn="ctr" indent="0" marL="0">
+                        <a:buNone/>
+                      </a:pPr>
+                      <a:r>
+                        <a:rPr lang="en-US" sz="1400" dirty="0">
+                          <a:solidFill>
+                            <a:srgbClr val="222222"/>
+                          </a:solidFill>
+                          <a:latin typeface="Noto Sans CJK KR" pitchFamily="34" charset="0"/>
+                          <a:ea typeface="Noto Sans CJK KR" pitchFamily="34" charset="-122"/>
+                          <a:cs typeface="Noto Sans CJK KR" pitchFamily="34" charset="-120"/>
+                        </a:rPr>
+                        <a:t>증가량</a:t>
+                      </a:r>
+                      <a:endParaRPr lang="en-US" sz="1400" dirty="0">
+                        <a:latin typeface="Noto Sans CJK KR" charset="0"/>
+                        <a:ea typeface="Noto Sans CJK KR" charset="0"/>
+                        <a:cs typeface="Noto Sans CJK KR" charset="0"/>
+                      </a:endParaRPr>
+                    </a:p>
+                  </a:txBody>
+                  <a:tcPr marL="91440" marR="91440" marT="45720" marB="45720">
+                    <a:lnL w="6350" cap="flat" cmpd="sng" algn="ctr">
+                      <a:solidFill>
+                        <a:srgbClr val="CCCCCC"/>
+                      </a:solidFill>
+                      <a:prstDash val="solid"/>
+                      <a:round/>
+                      <a:headEnd type="none" w="med" len="med"/>
+                      <a:tailEnd type="none" w="med" len="med"/>
+                    </a:lnL>
+                    <a:lnR w="6350" cap="flat" cmpd="sng" algn="ctr">
+                      <a:solidFill>
+                        <a:srgbClr val="CCCCCC"/>
+                      </a:solidFill>
+                      <a:prstDash val="solid"/>
+                      <a:round/>
+                      <a:headEnd type="none" w="med" len="med"/>
+                      <a:tailEnd type="none" w="med" len="med"/>
+                    </a:lnR>
+                    <a:lnT w="6350" cap="flat" cmpd="sng" algn="ctr">
+                      <a:solidFill>
+                        <a:srgbClr val="CCCCCC"/>
+                      </a:solidFill>
+                      <a:prstDash val="solid"/>
+                      <a:round/>
+                      <a:headEnd type="none" w="med" len="med"/>
+                      <a:tailEnd type="none" w="med" len="med"/>
+                    </a:lnT>
+                    <a:lnB w="6350" cap="flat" cmpd="sng" algn="ctr">
+                      <a:solidFill>
+                        <a:srgbClr val="CCCCCC"/>
+                      </a:solidFill>
+                      <a:prstDash val="solid"/>
+                      <a:round/>
+                      <a:headEnd type="none" w="med" len="med"/>
+                      <a:tailEnd type="none" w="med" len="med"/>
+                    </a:lnB>
+                  </a:tcPr>
+                </a:tc>
+                <a:tc>
+                  <a:txBody>
+                    <a:bodyPr/>
+                    <a:lstStyle/>
+                    <a:p>
+                      <a:pPr algn="ctr" indent="0" marL="0">
+                        <a:buNone/>
+                      </a:pPr>
+                      <a:r>
+                        <a:rPr lang="en-US" sz="1400" dirty="0">
+                          <a:solidFill>
+                            <a:srgbClr val="222222"/>
+                          </a:solidFill>
+                          <a:latin typeface="Noto Sans CJK KR" pitchFamily="34" charset="0"/>
+                          <a:ea typeface="Noto Sans CJK KR" pitchFamily="34" charset="-122"/>
+                          <a:cs typeface="Noto Sans CJK KR" pitchFamily="34" charset="-120"/>
+                        </a:rPr>
+                        <a:t>+1</a:t>
+                      </a:r>
+                      <a:endParaRPr lang="en-US" sz="1400" dirty="0">
+                        <a:latin typeface="Noto Sans CJK KR" charset="0"/>
+                        <a:ea typeface="Noto Sans CJK KR" charset="0"/>
+                        <a:cs typeface="Noto Sans CJK KR" charset="0"/>
+                      </a:endParaRPr>
+                    </a:p>
+                  </a:txBody>
+                  <a:tcPr marL="91440" marR="91440" marT="45720" marB="45720">
+                    <a:lnL w="6350" cap="flat" cmpd="sng" algn="ctr">
+                      <a:solidFill>
+                        <a:srgbClr val="CCCCCC"/>
+                      </a:solidFill>
+                      <a:prstDash val="solid"/>
+                      <a:round/>
+                      <a:headEnd type="none" w="med" len="med"/>
+                      <a:tailEnd type="none" w="med" len="med"/>
+                    </a:lnL>
+                    <a:lnR w="6350" cap="flat" cmpd="sng" algn="ctr">
+                      <a:solidFill>
+                        <a:srgbClr val="CCCCCC"/>
+                      </a:solidFill>
+                      <a:prstDash val="solid"/>
+                      <a:round/>
+                      <a:headEnd type="none" w="med" len="med"/>
+                      <a:tailEnd type="none" w="med" len="med"/>
+                    </a:lnR>
+                    <a:lnT w="6350" cap="flat" cmpd="sng" algn="ctr">
+                      <a:solidFill>
+                        <a:srgbClr val="CCCCCC"/>
+                      </a:solidFill>
+                      <a:prstDash val="solid"/>
+                      <a:round/>
+                      <a:headEnd type="none" w="med" len="med"/>
+                      <a:tailEnd type="none" w="med" len="med"/>
+                    </a:lnT>
+                    <a:lnB w="6350" cap="flat" cmpd="sng" algn="ctr">
+                      <a:solidFill>
+                        <a:srgbClr val="CCCCCC"/>
+                      </a:solidFill>
+                      <a:prstDash val="solid"/>
+                      <a:round/>
+                      <a:headEnd type="none" w="med" len="med"/>
+                      <a:tailEnd type="none" w="med" len="med"/>
+                    </a:lnB>
+                  </a:tcPr>
+                </a:tc>
+                <a:tc>
+                  <a:txBody>
+                    <a:bodyPr/>
+                    <a:lstStyle/>
+                    <a:p>
+                      <a:pPr algn="ctr" indent="0" marL="0">
+                        <a:buNone/>
+                      </a:pPr>
+                      <a:r>
+                        <a:rPr lang="en-US" sz="1400" dirty="0">
+                          <a:solidFill>
+                            <a:srgbClr val="222222"/>
+                          </a:solidFill>
+                          <a:latin typeface="Noto Sans CJK KR" pitchFamily="34" charset="0"/>
+                          <a:ea typeface="Noto Sans CJK KR" pitchFamily="34" charset="-122"/>
+                          <a:cs typeface="Noto Sans CJK KR" pitchFamily="34" charset="-120"/>
+                        </a:rPr>
+                        <a:t>+2</a:t>
+                      </a:r>
+                      <a:endParaRPr lang="en-US" sz="1400" dirty="0">
+                        <a:latin typeface="Noto Sans CJK KR" charset="0"/>
+                        <a:ea typeface="Noto Sans CJK KR" charset="0"/>
+                        <a:cs typeface="Noto Sans CJK KR" charset="0"/>
+                      </a:endParaRPr>
+                    </a:p>
+                  </a:txBody>
+                  <a:tcPr marL="91440" marR="91440" marT="45720" marB="45720">
+                    <a:lnL w="6350" cap="flat" cmpd="sng" algn="ctr">
+                      <a:solidFill>
+                        <a:srgbClr val="CCCCCC"/>
+                      </a:solidFill>
+                      <a:prstDash val="solid"/>
+                      <a:round/>
+                      <a:headEnd type="none" w="med" len="med"/>
+                      <a:tailEnd type="none" w="med" len="med"/>
+                    </a:lnL>
+                    <a:lnR w="6350" cap="flat" cmpd="sng" algn="ctr">
+                      <a:solidFill>
+                        <a:srgbClr val="CCCCCC"/>
+                      </a:solidFill>
+                      <a:prstDash val="solid"/>
+                      <a:round/>
+                      <a:headEnd type="none" w="med" len="med"/>
+                      <a:tailEnd type="none" w="med" len="med"/>
+                    </a:lnR>
+                    <a:lnT w="6350" cap="flat" cmpd="sng" algn="ctr">
+                      <a:solidFill>
+                        <a:srgbClr val="CCCCCC"/>
+                      </a:solidFill>
+                      <a:prstDash val="solid"/>
+                      <a:round/>
+                      <a:headEnd type="none" w="med" len="med"/>
+                      <a:tailEnd type="none" w="med" len="med"/>
+                    </a:lnT>
+                    <a:lnB w="6350" cap="flat" cmpd="sng" algn="ctr">
+                      <a:solidFill>
+                        <a:srgbClr val="CCCCCC"/>
+                      </a:solidFill>
+                      <a:prstDash val="solid"/>
+                      <a:round/>
+                      <a:headEnd type="none" w="med" len="med"/>
+                      <a:tailEnd type="none" w="med" len="med"/>
+                    </a:lnB>
+                  </a:tcPr>
+                </a:tc>
+                <a:tc>
+                  <a:txBody>
+                    <a:bodyPr/>
+                    <a:lstStyle/>
+                    <a:p>
+                      <a:pPr algn="ctr" indent="0" marL="0">
+                        <a:buNone/>
+                      </a:pPr>
+                      <a:r>
+                        <a:rPr lang="en-US" sz="1400" dirty="0">
+                          <a:solidFill>
+                            <a:srgbClr val="222222"/>
+                          </a:solidFill>
+                          <a:latin typeface="Noto Sans CJK KR" pitchFamily="34" charset="0"/>
+                          <a:ea typeface="Noto Sans CJK KR" pitchFamily="34" charset="-122"/>
+                          <a:cs typeface="Noto Sans CJK KR" pitchFamily="34" charset="-120"/>
+                        </a:rPr>
+                        <a:t>+4</a:t>
+                      </a:r>
+                      <a:endParaRPr lang="en-US" sz="1400" dirty="0">
+                        <a:latin typeface="Noto Sans CJK KR" charset="0"/>
+                        <a:ea typeface="Noto Sans CJK KR" charset="0"/>
+                        <a:cs typeface="Noto Sans CJK KR" charset="0"/>
+                      </a:endParaRPr>
+                    </a:p>
+                  </a:txBody>
+                  <a:tcPr marL="91440" marR="91440" marT="45720" marB="45720">
+                    <a:lnL w="6350" cap="flat" cmpd="sng" algn="ctr">
+                      <a:solidFill>
+                        <a:srgbClr val="CCCCCC"/>
+                      </a:solidFill>
+                      <a:prstDash val="solid"/>
+                      <a:round/>
+                      <a:headEnd type="none" w="med" len="med"/>
+                      <a:tailEnd type="none" w="med" len="med"/>
+                    </a:lnL>
+                    <a:lnR w="6350" cap="flat" cmpd="sng" algn="ctr">
+                      <a:solidFill>
+                        <a:srgbClr val="CCCCCC"/>
+                      </a:solidFill>
+                      <a:prstDash val="solid"/>
+                      <a:round/>
+                      <a:headEnd type="none" w="med" len="med"/>
+                      <a:tailEnd type="none" w="med" len="med"/>
+                    </a:lnR>
+                    <a:lnT w="6350" cap="flat" cmpd="sng" algn="ctr">
+                      <a:solidFill>
+                        <a:srgbClr val="CCCCCC"/>
+                      </a:solidFill>
+                      <a:prstDash val="solid"/>
+                      <a:round/>
+                      <a:headEnd type="none" w="med" len="med"/>
+                      <a:tailEnd type="none" w="med" len="med"/>
+                    </a:lnT>
+                    <a:lnB w="6350" cap="flat" cmpd="sng" algn="ctr">
+                      <a:solidFill>
+                        <a:srgbClr val="CCCCCC"/>
+                      </a:solidFill>
+                      <a:prstDash val="solid"/>
+                      <a:round/>
+                      <a:headEnd type="none" w="med" len="med"/>
+                      <a:tailEnd type="none" w="med" len="med"/>
+                    </a:lnB>
+                  </a:tcPr>
+                </a:tc>
+                <a:tc>
+                  <a:txBody>
+                    <a:bodyPr/>
+                    <a:lstStyle/>
+                    <a:p>
+                      <a:pPr algn="ctr" indent="0" marL="0">
+                        <a:buNone/>
+                      </a:pPr>
+                      <a:r>
+                        <a:rPr lang="en-US" sz="1400" dirty="0">
+                          <a:solidFill>
+                            <a:srgbClr val="222222"/>
+                          </a:solidFill>
+                          <a:latin typeface="Noto Sans CJK KR" pitchFamily="34" charset="0"/>
+                          <a:ea typeface="Noto Sans CJK KR" pitchFamily="34" charset="-122"/>
+                          <a:cs typeface="Noto Sans CJK KR" pitchFamily="34" charset="-120"/>
+                        </a:rPr>
+                        <a:t>+8</a:t>
+                      </a:r>
+                      <a:endParaRPr lang="en-US" sz="1400" dirty="0">
+                        <a:latin typeface="Noto Sans CJK KR" charset="0"/>
+                        <a:ea typeface="Noto Sans CJK KR" charset="0"/>
+                        <a:cs typeface="Noto Sans CJK KR" charset="0"/>
+                      </a:endParaRPr>
+                    </a:p>
+                  </a:txBody>
+                  <a:tcPr marL="91440" marR="91440" marT="45720" marB="45720">
+                    <a:lnL w="6350" cap="flat" cmpd="sng" algn="ctr">
+                      <a:solidFill>
+                        <a:srgbClr val="CCCCCC"/>
+                      </a:solidFill>
+                      <a:prstDash val="solid"/>
+                      <a:round/>
+                      <a:headEnd type="none" w="med" len="med"/>
+                      <a:tailEnd type="none" w="med" len="med"/>
+                    </a:lnL>
+                    <a:lnR w="6350" cap="flat" cmpd="sng" algn="ctr">
+                      <a:solidFill>
+                        <a:srgbClr val="CCCCCC"/>
+                      </a:solidFill>
+                      <a:prstDash val="solid"/>
+                      <a:round/>
+                      <a:headEnd type="none" w="med" len="med"/>
+                      <a:tailEnd type="none" w="med" len="med"/>
+                    </a:lnR>
+                    <a:lnT w="6350" cap="flat" cmpd="sng" algn="ctr">
+                      <a:solidFill>
+                        <a:srgbClr val="CCCCCC"/>
+                      </a:solidFill>
+                      <a:prstDash val="solid"/>
+                      <a:round/>
+                      <a:headEnd type="none" w="med" len="med"/>
+                      <a:tailEnd type="none" w="med" len="med"/>
+                    </a:lnT>
+                    <a:lnB w="6350" cap="flat" cmpd="sng" algn="ctr">
+                      <a:solidFill>
+                        <a:srgbClr val="CCCCCC"/>
+                      </a:solidFill>
+                      <a:prstDash val="solid"/>
+                      <a:round/>
+                      <a:headEnd type="none" w="med" len="med"/>
+                      <a:tailEnd type="none" w="med" len="med"/>
+                    </a:lnB>
+                  </a:tcPr>
+                </a:tc>
+                <a:tc>
+                  <a:txBody>
+                    <a:bodyPr/>
+                    <a:lstStyle/>
+                    <a:p>
+                      <a:pPr algn="ctr" indent="0" marL="0">
+                        <a:buNone/>
+                      </a:pPr>
+                      <a:r>
+                        <a:rPr lang="en-US" sz="1400" dirty="0">
+                          <a:solidFill>
+                            <a:srgbClr val="222222"/>
+                          </a:solidFill>
+                          <a:latin typeface="Noto Sans CJK KR" pitchFamily="34" charset="0"/>
+                          <a:ea typeface="Noto Sans CJK KR" pitchFamily="34" charset="-122"/>
+                          <a:cs typeface="Noto Sans CJK KR" pitchFamily="34" charset="-120"/>
+                        </a:rPr>
+                        <a:t>+16</a:t>
+                      </a:r>
+                      <a:endParaRPr lang="en-US" sz="1400" dirty="0">
+                        <a:latin typeface="Noto Sans CJK KR" charset="0"/>
+                        <a:ea typeface="Noto Sans CJK KR" charset="0"/>
+                        <a:cs typeface="Noto Sans CJK KR" charset="0"/>
+                      </a:endParaRPr>
+                    </a:p>
+                  </a:txBody>
+                  <a:tcPr marL="91440" marR="91440" marT="45720" marB="45720">
+                    <a:lnL w="6350" cap="flat" cmpd="sng" algn="ctr">
+                      <a:solidFill>
+                        <a:srgbClr val="CCCCCC"/>
+                      </a:solidFill>
+                      <a:prstDash val="solid"/>
+                      <a:round/>
+                      <a:headEnd type="none" w="med" len="med"/>
+                      <a:tailEnd type="none" w="med" len="med"/>
+                    </a:lnL>
+                    <a:lnR w="6350" cap="flat" cmpd="sng" algn="ctr">
+                      <a:solidFill>
+                        <a:srgbClr val="CCCCCC"/>
+                      </a:solidFill>
+                      <a:prstDash val="solid"/>
+                      <a:round/>
+                      <a:headEnd type="none" w="med" len="med"/>
+                      <a:tailEnd type="none" w="med" len="med"/>
+                    </a:lnR>
+                    <a:lnT w="6350" cap="flat" cmpd="sng" algn="ctr">
+                      <a:solidFill>
+                        <a:srgbClr val="CCCCCC"/>
+                      </a:solidFill>
+                      <a:prstDash val="solid"/>
+                      <a:round/>
+                      <a:headEnd type="none" w="med" len="med"/>
+                      <a:tailEnd type="none" w="med" len="med"/>
+                    </a:lnT>
+                    <a:lnB w="6350" cap="flat" cmpd="sng" algn="ctr">
+                      <a:solidFill>
+                        <a:srgbClr val="CCCCCC"/>
+                      </a:solidFill>
+                      <a:prstDash val="solid"/>
+                      <a:round/>
+                      <a:headEnd type="none" w="med" len="med"/>
+                      <a:tailEnd type="none" w="med" len="med"/>
+                    </a:lnB>
+                  </a:tcPr>
+                </a:tc>
+                <a:tc>
+                  <a:txBody>
+                    <a:bodyPr/>
+                    <a:lstStyle/>
+                    <a:p>
+                      <a:pPr algn="ctr" indent="0" marL="0">
+                        <a:buNone/>
+                      </a:pPr>
+                      <a:r>
+                        <a:rPr lang="en-US" sz="1400" dirty="0">
+                          <a:solidFill>
+                            <a:srgbClr val="222222"/>
+                          </a:solidFill>
+                          <a:latin typeface="Noto Sans CJK KR" pitchFamily="34" charset="0"/>
+                          <a:ea typeface="Noto Sans CJK KR" pitchFamily="34" charset="-122"/>
+                          <a:cs typeface="Noto Sans CJK KR" pitchFamily="34" charset="-120"/>
+                        </a:rPr>
+                        <a:t>+32</a:t>
+                      </a:r>
+                      <a:endParaRPr lang="en-US" sz="1400" dirty="0">
+                        <a:latin typeface="Noto Sans CJK KR" charset="0"/>
+                        <a:ea typeface="Noto Sans CJK KR" charset="0"/>
+                        <a:cs typeface="Noto Sans CJK KR" charset="0"/>
+                      </a:endParaRPr>
+                    </a:p>
+                  </a:txBody>
+                  <a:tcPr marL="91440" marR="91440" marT="45720" marB="45720">
+                    <a:lnL w="6350" cap="flat" cmpd="sng" algn="ctr">
+                      <a:solidFill>
+                        <a:srgbClr val="CCCCCC"/>
+                      </a:solidFill>
+                      <a:prstDash val="solid"/>
+                      <a:round/>
+                      <a:headEnd type="none" w="med" len="med"/>
+                      <a:tailEnd type="none" w="med" len="med"/>
+                    </a:lnL>
+                    <a:lnR w="6350" cap="flat" cmpd="sng" algn="ctr">
+                      <a:solidFill>
+                        <a:srgbClr val="CCCCCC"/>
+                      </a:solidFill>
+                      <a:prstDash val="solid"/>
+                      <a:round/>
+                      <a:headEnd type="none" w="med" len="med"/>
+                      <a:tailEnd type="none" w="med" len="med"/>
+                    </a:lnR>
+                    <a:lnT w="6350" cap="flat" cmpd="sng" algn="ctr">
+                      <a:solidFill>
+                        <a:srgbClr val="CCCCCC"/>
+                      </a:solidFill>
+                      <a:prstDash val="solid"/>
+                      <a:round/>
+                      <a:headEnd type="none" w="med" len="med"/>
+                      <a:tailEnd type="none" w="med" len="med"/>
+                    </a:lnT>
+                    <a:lnB w="6350" cap="flat" cmpd="sng" algn="ctr">
+                      <a:solidFill>
+                        <a:srgbClr val="CCCCCC"/>
+                      </a:solidFill>
+                      <a:prstDash val="solid"/>
+                      <a:round/>
+                      <a:headEnd type="none" w="med" len="med"/>
+                      <a:tailEnd type="none" w="med" len="med"/>
+                    </a:lnB>
+                  </a:tcPr>
+                </a:tc>
+                <a:tc>
+                  <a:txBody>
+                    <a:bodyPr/>
+                    <a:lstStyle/>
+                    <a:p>
+                      <a:pPr algn="ctr" indent="0" marL="0">
+                        <a:buNone/>
+                      </a:pPr>
+                      <a:r>
+                        <a:rPr lang="en-US" sz="1400" dirty="0">
+                          <a:solidFill>
+                            <a:srgbClr val="222222"/>
+                          </a:solidFill>
+                          <a:latin typeface="Noto Sans CJK KR" pitchFamily="34" charset="0"/>
+                          <a:ea typeface="Noto Sans CJK KR" pitchFamily="34" charset="-122"/>
+                          <a:cs typeface="Noto Sans CJK KR" pitchFamily="34" charset="-120"/>
+                        </a:rPr>
+                        <a:t>+64</a:t>
+                      </a:r>
+                      <a:endParaRPr lang="en-US" sz="1400" dirty="0">
+                        <a:latin typeface="Noto Sans CJK KR" charset="0"/>
+                        <a:ea typeface="Noto Sans CJK KR" charset="0"/>
+                        <a:cs typeface="Noto Sans CJK KR" charset="0"/>
+                      </a:endParaRPr>
+                    </a:p>
+                  </a:txBody>
+                  <a:tcPr marL="91440" marR="91440" marT="45720" marB="45720">
+                    <a:lnL w="6350" cap="flat" cmpd="sng" algn="ctr">
+                      <a:solidFill>
+                        <a:srgbClr val="CCCCCC"/>
+                      </a:solidFill>
+                      <a:prstDash val="solid"/>
+                      <a:round/>
+                      <a:headEnd type="none" w="med" len="med"/>
+                      <a:tailEnd type="none" w="med" len="med"/>
+                    </a:lnL>
+                    <a:lnR w="6350" cap="flat" cmpd="sng" algn="ctr">
+                      <a:solidFill>
+                        <a:srgbClr val="CCCCCC"/>
+                      </a:solidFill>
+                      <a:prstDash val="solid"/>
+                      <a:round/>
+                      <a:headEnd type="none" w="med" len="med"/>
+                      <a:tailEnd type="none" w="med" len="med"/>
+                    </a:lnR>
+                    <a:lnT w="6350" cap="flat" cmpd="sng" algn="ctr">
+                      <a:solidFill>
+                        <a:srgbClr val="CCCCCC"/>
+                      </a:solidFill>
+                      <a:prstDash val="solid"/>
+                      <a:round/>
+                      <a:headEnd type="none" w="med" len="med"/>
+                      <a:tailEnd type="none" w="med" len="med"/>
+                    </a:lnT>
+                    <a:lnB w="6350" cap="flat" cmpd="sng" algn="ctr">
+                      <a:solidFill>
+                        <a:srgbClr val="CCCCCC"/>
+                      </a:solidFill>
+                      <a:prstDash val="solid"/>
+                      <a:round/>
+                      <a:headEnd type="none" w="med" len="med"/>
+                      <a:tailEnd type="none" w="med" len="med"/>
+                    </a:lnB>
+                  </a:tcPr>
+                </a:tc>
+                <a:tc>
+                  <a:txBody>
+                    <a:bodyPr/>
+                    <a:lstStyle/>
+                    <a:p>
+                      <a:pPr algn="ctr" indent="0" marL="0">
+                        <a:buNone/>
+                      </a:pPr>
+                      <a:r>
+                        <a:rPr lang="en-US" sz="1400" dirty="0">
+                          <a:solidFill>
+                            <a:srgbClr val="222222"/>
+                          </a:solidFill>
+                          <a:latin typeface="Noto Sans CJK KR" pitchFamily="34" charset="0"/>
+                          <a:ea typeface="Noto Sans CJK KR" pitchFamily="34" charset="-122"/>
+                          <a:cs typeface="Noto Sans CJK KR" pitchFamily="34" charset="-120"/>
+                        </a:rPr>
+                        <a:t>+128</a:t>
+                      </a:r>
+                      <a:endParaRPr lang="en-US" sz="1400" dirty="0">
+                        <a:latin typeface="Noto Sans CJK KR" charset="0"/>
+                        <a:ea typeface="Noto Sans CJK KR" charset="0"/>
+                        <a:cs typeface="Noto Sans CJK KR" charset="0"/>
+                      </a:endParaRPr>
+                    </a:p>
+                  </a:txBody>
+                  <a:tcPr marL="91440" marR="91440" marT="45720" marB="45720">
+                    <a:lnL w="6350" cap="flat" cmpd="sng" algn="ctr">
+                      <a:solidFill>
+                        <a:srgbClr val="CCCCCC"/>
+                      </a:solidFill>
+                      <a:prstDash val="solid"/>
+                      <a:round/>
+                      <a:headEnd type="none" w="med" len="med"/>
+                      <a:tailEnd type="none" w="med" len="med"/>
+                    </a:lnL>
+                    <a:lnR w="6350" cap="flat" cmpd="sng" algn="ctr">
+                      <a:solidFill>
+                        <a:srgbClr val="CCCCCC"/>
+                      </a:solidFill>
+                      <a:prstDash val="solid"/>
+                      <a:round/>
+                      <a:headEnd type="none" w="med" len="med"/>
+                      <a:tailEnd type="none" w="med" len="med"/>
+                    </a:lnR>
+                    <a:lnT w="6350" cap="flat" cmpd="sng" algn="ctr">
+                      <a:solidFill>
+                        <a:srgbClr val="CCCCCC"/>
+                      </a:solidFill>
+                      <a:prstDash val="solid"/>
+                      <a:round/>
+                      <a:headEnd type="none" w="med" len="med"/>
+                      <a:tailEnd type="none" w="med" len="med"/>
+                    </a:lnT>
+                    <a:lnB w="6350" cap="flat" cmpd="sng" algn="ctr">
+                      <a:solidFill>
+                        <a:srgbClr val="CCCCCC"/>
+                      </a:solidFill>
+                      <a:prstDash val="solid"/>
+                      <a:round/>
+                      <a:headEnd type="none" w="med" len="med"/>
+                      <a:tailEnd type="none" w="med" len="med"/>
+                    </a:lnB>
+                  </a:tcPr>
+                </a:tc>
+              </a:tr>
+            </a:tbl>
+          </a:graphicData>
+        </a:graphic>
+      </p:graphicFrame>
+      <p:sp>
+        <p:nvSpPr>
+          <p:cNvPr id="5" name="Text 2"/>
+          <p:cNvSpPr/>
+          <p:nvPr/>
+        </p:nvSpPr>
+        <p:spPr>
+          <a:xfrm>
+            <a:off x="8503920" y="4754880"/>
+            <a:ext cx="457200" cy="274320"/>
+          </a:xfrm>
+          <a:prstGeom prst="rect">
+            <a:avLst/>
+          </a:prstGeom>
+          <a:noFill/>
+          <a:ln/>
+        </p:spPr>
+        <p:txBody>
+          <a:bodyPr wrap="square" rtlCol="0" anchor="ctr"/>
+          <a:lstStyle/>
+          <a:p>
+            <a:pPr algn="r" indent="0" marL="0">
+              <a:buNone/>
+            </a:pPr>
+            <a:r>
+              <a:rPr lang="en-US" sz="1200" dirty="0">
+                <a:solidFill>
+                  <a:srgbClr val="999999"/>
+                </a:solidFill>
+                <a:latin typeface="Noto Sans CJK KR" pitchFamily="34" charset="0"/>
+                <a:ea typeface="Noto Sans CJK KR" pitchFamily="34" charset="-122"/>
+                <a:cs typeface="Noto Sans CJK KR" pitchFamily="34" charset="-120"/>
+              </a:rPr>
+              <a:t>12</a:t>
+            </a:r>
+            <a:endParaRPr lang="en-US" sz="1200" dirty="0"/>
+          </a:p>
+        </p:txBody>
+      </p:sp>
+    </p:spTree>
+  </p:cSld>
+  <p:clrMapOvr>
+    <a:masterClrMapping/>
+  </p:clrMapOvr>
+</p:sld>
+</file>
+
+<file path=ppt/slides/slide13.xml><?xml version="1.0" encoding="utf-8"?>
+<p:sld xmlns:a="http://schemas.openxmlformats.org/drawingml/2006/main" xmlns:r="http://schemas.openxmlformats.org/officeDocument/2006/relationships" xmlns:p="http://schemas.openxmlformats.org/presentationml/2006/main">
+  <p:cSld name="Slide 13">
+    <p:spTree>
+      <p:nvGrpSpPr>
+        <p:cNvPr id="1" name=""/>
+        <p:cNvGrpSpPr/>
+        <p:nvPr/>
+      </p:nvGrpSpPr>
+      <p:grpSpPr>
+        <a:xfrm>
+          <a:off x="0" y="0"/>
+          <a:ext cx="0" cy="0"/>
+          <a:chOff x="0" y="0"/>
+          <a:chExt cx="0" cy="0"/>
+        </a:xfrm>
+      </p:grpSpPr>
+      <p:sp>
+        <p:nvSpPr>
+          <p:cNvPr id="2" name="Text 0"/>
+          <p:cNvSpPr/>
+          <p:nvPr/>
+        </p:nvSpPr>
+        <p:spPr>
+          <a:xfrm>
+            <a:off x="548640" y="274320"/>
+            <a:ext cx="8046720" cy="777240"/>
+          </a:xfrm>
+          <a:prstGeom prst="rect">
+            <a:avLst/>
+          </a:prstGeom>
+          <a:noFill/>
+          <a:ln/>
+        </p:spPr>
+        <p:txBody>
+          <a:bodyPr wrap="square" lIns="0" tIns="0" rIns="0" bIns="0" rtlCol="0" anchor="ctr"/>
+          <a:lstStyle/>
+          <a:p>
+            <a:pPr indent="0" marL="0">
+              <a:buNone/>
+            </a:pPr>
+            <a:r>
+              <a:rPr lang="en-US" sz="3600" b="1" dirty="0">
+                <a:solidFill>
+                  <a:srgbClr val="111111"/>
+                </a:solidFill>
+                <a:latin typeface="Noto Sans CJK KR" pitchFamily="34" charset="0"/>
+                <a:ea typeface="Noto Sans CJK KR" pitchFamily="34" charset="-122"/>
+                <a:cs typeface="Noto Sans CJK KR" pitchFamily="34" charset="-120"/>
+              </a:rPr>
+              <a:t>클럭 동기의 어려움</a:t>
+            </a:r>
+            <a:endParaRPr lang="en-US" sz="3600" dirty="0"/>
+          </a:p>
+        </p:txBody>
+      </p:sp>
+      <p:sp>
+        <p:nvSpPr>
+          <p:cNvPr id="3" name="Text 1"/>
+          <p:cNvSpPr/>
+          <p:nvPr/>
+        </p:nvSpPr>
+        <p:spPr>
+          <a:xfrm>
+            <a:off x="548640" y="1234440"/>
+            <a:ext cx="8046720" cy="2971800"/>
+          </a:xfrm>
+          <a:prstGeom prst="rect">
+            <a:avLst/>
+          </a:prstGeom>
+          <a:noFill/>
+          <a:ln/>
+        </p:spPr>
+        <p:txBody>
+          <a:bodyPr wrap="square" rtlCol="0" anchor="t"/>
+          <a:lstStyle/>
+          <a:p>
+            <a:pPr marL="342900" indent="-342900">
+              <a:spcAft>
+                <a:spcPts val="1200"/>
+              </a:spcAft>
+              <a:buSzPct val="100000"/>
+              <a:buChar char="•"/>
+            </a:pPr>
+            <a:r>
+              <a:rPr lang="en-US" sz="2000" dirty="0">
+                <a:solidFill>
+                  <a:srgbClr val="222222"/>
+                </a:solidFill>
+                <a:latin typeface="Noto Sans CJK KR" pitchFamily="34" charset="0"/>
+                <a:ea typeface="Noto Sans CJK KR" pitchFamily="34" charset="-122"/>
+                <a:cs typeface="Noto Sans CJK KR" pitchFamily="34" charset="-120"/>
+              </a:rPr>
+              <a:t>Master·Slave는 클럭을 공유하지 않음 — 클럭 오차가 통신에 치명적인 방해 요인</a:t>
+            </a:r>
+            <a:endParaRPr lang="en-US" sz="2000" dirty="0"/>
+          </a:p>
+          <a:p>
+            <a:pPr marL="342900" indent="-342900">
+              <a:spcAft>
+                <a:spcPts val="1200"/>
+              </a:spcAft>
+              <a:buSzPct val="100000"/>
+              <a:buChar char="•"/>
+            </a:pPr>
+            <a:r>
+              <a:rPr lang="en-US" sz="2000" dirty="0">
+                <a:solidFill>
+                  <a:srgbClr val="222222"/>
+                </a:solidFill>
+                <a:latin typeface="Noto Sans CJK KR" pitchFamily="34" charset="0"/>
+                <a:ea typeface="Noto Sans CJK KR" pitchFamily="34" charset="-122"/>
+                <a:cs typeface="Noto Sans CJK KR" pitchFamily="34" charset="-120"/>
+              </a:rPr>
+              <a:t>DIV 값을 AXI 레지스터로 설정해 클럭을 분주, Master·Slave 양쪽에 동일한 DIV 값을 쓴다고 가정</a:t>
+            </a:r>
+            <a:endParaRPr lang="en-US" sz="2000" dirty="0"/>
+          </a:p>
+          <a:p>
+            <a:pPr marL="342900" indent="-342900">
+              <a:spcAft>
+                <a:spcPts val="1200"/>
+              </a:spcAft>
+              <a:buSzPct val="100000"/>
+              <a:buChar char="•"/>
+            </a:pPr>
+            <a:r>
+              <a:rPr lang="en-US" sz="2000" dirty="0">
+                <a:solidFill>
+                  <a:srgbClr val="222222"/>
+                </a:solidFill>
+                <a:latin typeface="Noto Sans CJK KR" pitchFamily="34" charset="0"/>
+                <a:ea typeface="Noto Sans CJK KR" pitchFamily="34" charset="-122"/>
+                <a:cs typeface="Noto Sans CJK KR" pitchFamily="34" charset="-120"/>
+              </a:rPr>
+              <a:t>분주 클럭은 메인 클럭 / (DIV + 1)</a:t>
+            </a:r>
+            <a:endParaRPr lang="en-US" sz="2000" dirty="0"/>
+          </a:p>
+          <a:p>
+            <a:pPr marL="342900" indent="-342900">
+              <a:spcAft>
+                <a:spcPts val="1200"/>
+              </a:spcAft>
+              <a:buSzPct val="100000"/>
+              <a:buChar char="•"/>
+            </a:pPr>
+            <a:r>
+              <a:rPr lang="en-US" sz="2000" dirty="0">
+                <a:solidFill>
+                  <a:srgbClr val="222222"/>
+                </a:solidFill>
+                <a:latin typeface="Noto Sans CJK KR" pitchFamily="34" charset="0"/>
+                <a:ea typeface="Noto Sans CJK KR" pitchFamily="34" charset="-122"/>
+                <a:cs typeface="Noto Sans CJK KR" pitchFamily="34" charset="-120"/>
+              </a:rPr>
+              <a:t>수신 샘플링은 비트 구간의 중간 지점에서 1회만 수행</a:t>
+            </a:r>
+            <a:endParaRPr lang="en-US" sz="2000" dirty="0"/>
+          </a:p>
+        </p:txBody>
+      </p:sp>
+      <p:sp>
+        <p:nvSpPr>
+          <p:cNvPr id="4" name="Text 2"/>
+          <p:cNvSpPr/>
+          <p:nvPr/>
+        </p:nvSpPr>
+        <p:spPr>
+          <a:xfrm>
+            <a:off x="8503920" y="4754880"/>
+            <a:ext cx="457200" cy="274320"/>
+          </a:xfrm>
+          <a:prstGeom prst="rect">
+            <a:avLst/>
+          </a:prstGeom>
+          <a:noFill/>
+          <a:ln/>
+        </p:spPr>
+        <p:txBody>
+          <a:bodyPr wrap="square" rtlCol="0" anchor="ctr"/>
+          <a:lstStyle/>
+          <a:p>
+            <a:pPr algn="r" indent="0" marL="0">
+              <a:buNone/>
+            </a:pPr>
+            <a:r>
+              <a:rPr lang="en-US" sz="1200" dirty="0">
+                <a:solidFill>
+                  <a:srgbClr val="999999"/>
+                </a:solidFill>
+                <a:latin typeface="Noto Sans CJK KR" pitchFamily="34" charset="0"/>
+                <a:ea typeface="Noto Sans CJK KR" pitchFamily="34" charset="-122"/>
+                <a:cs typeface="Noto Sans CJK KR" pitchFamily="34" charset="-120"/>
+              </a:rPr>
+              <a:t>13</a:t>
+            </a:r>
+            <a:endParaRPr lang="en-US" sz="1200" dirty="0"/>
+          </a:p>
+        </p:txBody>
+      </p:sp>
+    </p:spTree>
+  </p:cSld>
+  <p:clrMapOvr>
+    <a:masterClrMapping/>
+  </p:clrMapOvr>
+</p:sld>
+</file>
+
+<file path=ppt/slides/slide14.xml><?xml version="1.0" encoding="utf-8"?>
+<p:sld xmlns:a="http://schemas.openxmlformats.org/drawingml/2006/main" xmlns:r="http://schemas.openxmlformats.org/officeDocument/2006/relationships" xmlns:p="http://schemas.openxmlformats.org/presentationml/2006/main">
+  <p:cSld name="Slide 14">
+    <p:spTree>
+      <p:nvGrpSpPr>
+        <p:cNvPr id="1" name=""/>
+        <p:cNvGrpSpPr/>
+        <p:nvPr/>
+      </p:nvGrpSpPr>
+      <p:grpSpPr>
+        <a:xfrm>
+          <a:off x="0" y="0"/>
+          <a:ext cx="0" cy="0"/>
+          <a:chOff x="0" y="0"/>
+          <a:chExt cx="0" cy="0"/>
+        </a:xfrm>
+      </p:grpSpPr>
+      <p:sp>
+        <p:nvSpPr>
+          <p:cNvPr id="2" name="Text 0"/>
+          <p:cNvSpPr/>
+          <p:nvPr/>
+        </p:nvSpPr>
+        <p:spPr>
+          <a:xfrm>
+            <a:off x="548640" y="274320"/>
+            <a:ext cx="8046720" cy="777240"/>
+          </a:xfrm>
+          <a:prstGeom prst="rect">
+            <a:avLst/>
+          </a:prstGeom>
+          <a:noFill/>
+          <a:ln/>
+        </p:spPr>
+        <p:txBody>
+          <a:bodyPr wrap="square" lIns="0" tIns="0" rIns="0" bIns="0" rtlCol="0" anchor="ctr"/>
+          <a:lstStyle/>
+          <a:p>
+            <a:pPr indent="0" marL="0">
+              <a:buNone/>
+            </a:pPr>
+            <a:r>
+              <a:rPr lang="en-US" sz="3600" b="1" dirty="0">
+                <a:solidFill>
+                  <a:srgbClr val="111111"/>
+                </a:solidFill>
+                <a:latin typeface="Noto Sans CJK KR" pitchFamily="34" charset="0"/>
+                <a:ea typeface="Noto Sans CJK KR" pitchFamily="34" charset="-122"/>
+                <a:cs typeface="Noto Sans CJK KR" pitchFamily="34" charset="-120"/>
+              </a:rPr>
+              <a:t>Master의 고장 처리</a:t>
+            </a:r>
+            <a:endParaRPr lang="en-US" sz="3600" dirty="0"/>
+          </a:p>
+        </p:txBody>
+      </p:sp>
+      <p:sp>
+        <p:nvSpPr>
+          <p:cNvPr id="3" name="Text 1"/>
+          <p:cNvSpPr/>
+          <p:nvPr/>
+        </p:nvSpPr>
+        <p:spPr>
+          <a:xfrm>
+            <a:off x="548640" y="1234440"/>
+            <a:ext cx="8046720" cy="2971800"/>
+          </a:xfrm>
+          <a:prstGeom prst="rect">
+            <a:avLst/>
+          </a:prstGeom>
+          <a:noFill/>
+          <a:ln/>
+        </p:spPr>
+        <p:txBody>
+          <a:bodyPr wrap="square" rtlCol="0" anchor="t"/>
+          <a:lstStyle/>
+          <a:p>
+            <a:pPr marL="342900" indent="-342900">
+              <a:spcAft>
+                <a:spcPts val="1200"/>
+              </a:spcAft>
+              <a:buSzPct val="100000"/>
+              <a:buChar char="•"/>
+            </a:pPr>
+            <a:r>
+              <a:rPr lang="en-US" sz="2000" dirty="0">
+                <a:solidFill>
+                  <a:srgbClr val="222222"/>
+                </a:solidFill>
+                <a:latin typeface="Noto Sans CJK KR" pitchFamily="34" charset="0"/>
+                <a:ea typeface="Noto Sans CJK KR" pitchFamily="34" charset="-122"/>
+                <a:cs typeface="Noto Sans CJK KR" pitchFamily="34" charset="-120"/>
+              </a:rPr>
+              <a:t>슬롯별 4가지 카운터(preamble_err_cnt, slot_timeout_cnt, hamming_err_cnt, silent_cnt)로 임계치 기반 고장 판정</a:t>
+            </a:r>
+            <a:endParaRPr lang="en-US" sz="2000" dirty="0"/>
+          </a:p>
+          <a:p>
+            <a:pPr marL="342900" indent="-342900">
+              <a:spcAft>
+                <a:spcPts val="1200"/>
+              </a:spcAft>
+              <a:buSzPct val="100000"/>
+              <a:buChar char="•"/>
+            </a:pPr>
+            <a:r>
+              <a:rPr lang="en-US" sz="2000" dirty="0">
+                <a:solidFill>
+                  <a:srgbClr val="222222"/>
+                </a:solidFill>
+                <a:latin typeface="Noto Sans CJK KR" pitchFamily="34" charset="0"/>
+                <a:ea typeface="Noto Sans CJK KR" pitchFamily="34" charset="-122"/>
+                <a:cs typeface="Noto Sans CJK KR" pitchFamily="34" charset="-120"/>
+              </a:rPr>
+              <a:t>slot_timeout_cnt는 심각한 타이밍/주소 불일치 시 즉시 255로 saturate, 약한 가드 경계 오류 시 +6</a:t>
+            </a:r>
+            <a:endParaRPr lang="en-US" sz="2000" dirty="0"/>
+          </a:p>
+          <a:p>
+            <a:pPr marL="342900" indent="-342900">
+              <a:spcAft>
+                <a:spcPts val="1200"/>
+              </a:spcAft>
+              <a:buSzPct val="100000"/>
+              <a:buChar char="•"/>
+            </a:pPr>
+            <a:r>
+              <a:rPr lang="en-US" sz="2000" dirty="0">
+                <a:solidFill>
+                  <a:srgbClr val="222222"/>
+                </a:solidFill>
+                <a:latin typeface="Noto Sans CJK KR" pitchFamily="34" charset="0"/>
+                <a:ea typeface="Noto Sans CJK KR" pitchFamily="34" charset="-122"/>
+                <a:cs typeface="Noto Sans CJK KR" pitchFamily="34" charset="-120"/>
+              </a:rPr>
+              <a:t>판정 임곗값(FAULT_TH, SILENT_TH)은 PS가 AXI 레지스터로 설정</a:t>
+            </a:r>
+            <a:endParaRPr lang="en-US" sz="2000" dirty="0"/>
+          </a:p>
+          <a:p>
+            <a:pPr marL="342900" indent="-342900">
+              <a:spcAft>
+                <a:spcPts val="1200"/>
+              </a:spcAft>
+              <a:buSzPct val="100000"/>
+              <a:buChar char="•"/>
+            </a:pPr>
+            <a:r>
+              <a:rPr lang="en-US" sz="2000" dirty="0">
+                <a:solidFill>
+                  <a:srgbClr val="222222"/>
+                </a:solidFill>
+                <a:latin typeface="Noto Sans CJK KR" pitchFamily="34" charset="0"/>
+                <a:ea typeface="Noto Sans CJK KR" pitchFamily="34" charset="-122"/>
+                <a:cs typeface="Noto Sans CJK KR" pitchFamily="34" charset="-120"/>
+              </a:rPr>
+              <a:t>(preamble_err_cnt + slot_timeout_cnt + hamming_err_cnt) &gt; FAULT_TH 이면 halt_cmd=1 → 동기 프레임에 실어 전송 (silent_cnt는 표시용으로 합산에서 제외)</a:t>
+            </a:r>
+            <a:endParaRPr lang="en-US" sz="2000" dirty="0"/>
+          </a:p>
+        </p:txBody>
+      </p:sp>
+      <p:sp>
+        <p:nvSpPr>
+          <p:cNvPr id="4" name="Text 2"/>
+          <p:cNvSpPr/>
+          <p:nvPr/>
+        </p:nvSpPr>
+        <p:spPr>
+          <a:xfrm>
+            <a:off x="8503920" y="4754880"/>
+            <a:ext cx="457200" cy="274320"/>
+          </a:xfrm>
+          <a:prstGeom prst="rect">
+            <a:avLst/>
+          </a:prstGeom>
+          <a:noFill/>
+          <a:ln/>
+        </p:spPr>
+        <p:txBody>
+          <a:bodyPr wrap="square" rtlCol="0" anchor="ctr"/>
+          <a:lstStyle/>
+          <a:p>
+            <a:pPr algn="r" indent="0" marL="0">
+              <a:buNone/>
+            </a:pPr>
+            <a:r>
+              <a:rPr lang="en-US" sz="1200" dirty="0">
+                <a:solidFill>
+                  <a:srgbClr val="999999"/>
+                </a:solidFill>
+                <a:latin typeface="Noto Sans CJK KR" pitchFamily="34" charset="0"/>
+                <a:ea typeface="Noto Sans CJK KR" pitchFamily="34" charset="-122"/>
+                <a:cs typeface="Noto Sans CJK KR" pitchFamily="34" charset="-120"/>
+              </a:rPr>
+              <a:t>14</a:t>
+            </a:r>
+            <a:endParaRPr lang="en-US" sz="1200" dirty="0"/>
+          </a:p>
+        </p:txBody>
+      </p:sp>
+    </p:spTree>
+  </p:cSld>
+  <p:clrMapOvr>
+    <a:masterClrMapping/>
+  </p:clrMapOvr>
+</p:sld>
+</file>
+
+<file path=ppt/slides/slide15.xml><?xml version="1.0" encoding="utf-8"?>
+<p:sld xmlns:a="http://schemas.openxmlformats.org/drawingml/2006/main" xmlns:r="http://schemas.openxmlformats.org/officeDocument/2006/relationships" xmlns:p="http://schemas.openxmlformats.org/presentationml/2006/main">
+  <p:cSld name="Slide 15">
+    <p:spTree>
+      <p:nvGrpSpPr>
+        <p:cNvPr id="1" name=""/>
+        <p:cNvGrpSpPr/>
+        <p:nvPr/>
+      </p:nvGrpSpPr>
+      <p:grpSpPr>
+        <a:xfrm>
+          <a:off x="0" y="0"/>
+          <a:ext cx="0" cy="0"/>
+          <a:chOff x="0" y="0"/>
+          <a:chExt cx="0" cy="0"/>
+        </a:xfrm>
+      </p:grpSpPr>
+      <p:sp>
+        <p:nvSpPr>
+          <p:cNvPr id="2" name="Text 0"/>
+          <p:cNvSpPr/>
+          <p:nvPr/>
+        </p:nvSpPr>
+        <p:spPr>
+          <a:xfrm>
+            <a:off x="548640" y="274320"/>
+            <a:ext cx="8046720" cy="777240"/>
+          </a:xfrm>
+          <a:prstGeom prst="rect">
+            <a:avLst/>
+          </a:prstGeom>
+          <a:noFill/>
+          <a:ln/>
+        </p:spPr>
+        <p:txBody>
+          <a:bodyPr wrap="square" lIns="0" tIns="0" rIns="0" bIns="0" rtlCol="0" anchor="ctr"/>
+          <a:lstStyle/>
+          <a:p>
+            <a:pPr indent="0" marL="0">
+              <a:buNone/>
+            </a:pPr>
+            <a:r>
+              <a:rPr lang="en-US" sz="3600" b="1" dirty="0">
+                <a:solidFill>
+                  <a:srgbClr val="111111"/>
+                </a:solidFill>
+                <a:latin typeface="Noto Sans CJK KR" pitchFamily="34" charset="0"/>
+                <a:ea typeface="Noto Sans CJK KR" pitchFamily="34" charset="-122"/>
+                <a:cs typeface="Noto Sans CJK KR" pitchFamily="34" charset="-120"/>
+              </a:rPr>
+              <a:t>Master 고장 처리 흐름도</a:t>
+            </a:r>
+            <a:endParaRPr lang="en-US" sz="3600" dirty="0"/>
+          </a:p>
+        </p:txBody>
+      </p:sp>
+      <p:sp>
+        <p:nvSpPr>
+          <p:cNvPr id="3" name="Text 1"/>
+          <p:cNvSpPr/>
+          <p:nvPr/>
+        </p:nvSpPr>
+        <p:spPr>
+          <a:xfrm>
+            <a:off x="548640" y="1188720"/>
+            <a:ext cx="8046720" cy="685800"/>
+          </a:xfrm>
+          <a:prstGeom prst="rect">
+            <a:avLst/>
+          </a:prstGeom>
+          <a:noFill/>
+          <a:ln/>
+        </p:spPr>
+        <p:txBody>
+          <a:bodyPr wrap="square" rtlCol="0" anchor="t"/>
+          <a:lstStyle/>
+          <a:p>
+            <a:pPr marL="342900" indent="-342900">
+              <a:spcAft>
+                <a:spcPts val="600"/>
+              </a:spcAft>
+              <a:buSzPct val="100000"/>
+              <a:buChar char="•"/>
+            </a:pPr>
+            <a:r>
+              <a:rPr lang="en-US" sz="1600" dirty="0">
+                <a:solidFill>
+                  <a:srgbClr val="222222"/>
+                </a:solidFill>
+                <a:latin typeface="Noto Sans CJK KR" pitchFamily="34" charset="0"/>
+                <a:ea typeface="Noto Sans CJK KR" pitchFamily="34" charset="-122"/>
+                <a:cs typeface="Noto Sans CJK KR" pitchFamily="34" charset="-120"/>
+              </a:rPr>
+              <a:t>슬롯마다 프리앰블 → 타이밍 → Hamming 순으로 검사</a:t>
+            </a:r>
+            <a:endParaRPr lang="en-US" sz="1600" dirty="0"/>
+          </a:p>
+          <a:p>
+            <a:pPr marL="342900" indent="-342900">
+              <a:spcAft>
+                <a:spcPts val="600"/>
+              </a:spcAft>
+              <a:buSzPct val="100000"/>
+              <a:buChar char="•"/>
+            </a:pPr>
+            <a:r>
+              <a:rPr lang="en-US" sz="1600" dirty="0">
+                <a:solidFill>
+                  <a:srgbClr val="222222"/>
+                </a:solidFill>
+                <a:latin typeface="Noto Sans CJK KR" pitchFamily="34" charset="0"/>
+                <a:ea typeface="Noto Sans CJK KR" pitchFamily="34" charset="-122"/>
+                <a:cs typeface="Noto Sans CJK KR" pitchFamily="34" charset="-120"/>
+              </a:rPr>
+              <a:t>각 단계의 오류는 해당 카운터를 증가시킴</a:t>
+            </a:r>
+            <a:endParaRPr lang="en-US" sz="1600" dirty="0"/>
+          </a:p>
+          <a:p>
+            <a:pPr marL="342900" indent="-342900">
+              <a:spcAft>
+                <a:spcPts val="600"/>
+              </a:spcAft>
+              <a:buSzPct val="100000"/>
+              <a:buChar char="•"/>
+            </a:pPr>
+            <a:r>
+              <a:rPr lang="en-US" sz="1600" dirty="0">
+                <a:solidFill>
+                  <a:srgbClr val="222222"/>
+                </a:solidFill>
+                <a:latin typeface="Noto Sans CJK KR" pitchFamily="34" charset="0"/>
+                <a:ea typeface="Noto Sans CJK KR" pitchFamily="34" charset="-122"/>
+                <a:cs typeface="Noto Sans CJK KR" pitchFamily="34" charset="-120"/>
+              </a:rPr>
+              <a:t>누적합이 FAULT_TH를 넘으면 halt_cmd=1, 이후 카운터는 동결됨</a:t>
+            </a:r>
+            <a:endParaRPr lang="en-US" sz="1600" dirty="0"/>
+          </a:p>
+          <a:p>
+            <a:pPr marL="342900" indent="-342900">
+              <a:spcAft>
+                <a:spcPts val="600"/>
+              </a:spcAft>
+              <a:buSzPct val="100000"/>
+              <a:buChar char="•"/>
+            </a:pPr>
+            <a:r>
+              <a:rPr lang="en-US" sz="1600" dirty="0">
+                <a:solidFill>
+                  <a:srgbClr val="222222"/>
+                </a:solidFill>
+                <a:latin typeface="Noto Sans CJK KR" pitchFamily="34" charset="0"/>
+                <a:ea typeface="Noto Sans CJK KR" pitchFamily="34" charset="-122"/>
+                <a:cs typeface="Noto Sans CJK KR" pitchFamily="34" charset="-120"/>
+              </a:rPr>
+              <a:t>halt_cmd는 리셋 전까지 유지되며, 취소 경로는 없음</a:t>
+            </a:r>
+            <a:endParaRPr lang="en-US" sz="1600" dirty="0"/>
+          </a:p>
+        </p:txBody>
+      </p:sp>
+      <p:pic>
+        <p:nvPicPr>
+          <p:cNvPr id="4" name="Image 0" descr="/home/user/SoC_Design_and_Programming/diagrams/section3/zoom/master_fault_flow.png">    </p:cNvPr>
+          <p:cNvPicPr>
+            <a:picLocks noChangeAspect="1"/>
+          </p:cNvPicPr>
+          <p:nvPr/>
+        </p:nvPicPr>
+        <p:blipFill>
+          <a:blip r:embed="rId1"/>
+          <a:srcRect l="0" r="0" t="0" b="0"/>
+          <a:stretch/>
+        </p:blipFill>
+        <p:spPr>
+          <a:xfrm>
+            <a:off x="548640" y="2404499"/>
+            <a:ext cx="8046720" cy="1683242"/>
+          </a:xfrm>
+          <a:prstGeom prst="rect">
+            <a:avLst/>
+          </a:prstGeom>
+        </p:spPr>
+      </p:pic>
+      <p:sp>
+        <p:nvSpPr>
+          <p:cNvPr id="5" name="Text 2"/>
+          <p:cNvSpPr/>
+          <p:nvPr/>
+        </p:nvSpPr>
+        <p:spPr>
+          <a:xfrm>
+            <a:off x="8503920" y="4754880"/>
+            <a:ext cx="457200" cy="274320"/>
+          </a:xfrm>
+          <a:prstGeom prst="rect">
+            <a:avLst/>
+          </a:prstGeom>
+          <a:noFill/>
+          <a:ln/>
+        </p:spPr>
+        <p:txBody>
+          <a:bodyPr wrap="square" rtlCol="0" anchor="ctr"/>
+          <a:lstStyle/>
+          <a:p>
+            <a:pPr algn="r" indent="0" marL="0">
+              <a:buNone/>
+            </a:pPr>
+            <a:r>
+              <a:rPr lang="en-US" sz="1200" dirty="0">
+                <a:solidFill>
+                  <a:srgbClr val="999999"/>
+                </a:solidFill>
+                <a:latin typeface="Noto Sans CJK KR" pitchFamily="34" charset="0"/>
+                <a:ea typeface="Noto Sans CJK KR" pitchFamily="34" charset="-122"/>
+                <a:cs typeface="Noto Sans CJK KR" pitchFamily="34" charset="-120"/>
+              </a:rPr>
+              <a:t>15</a:t>
+            </a:r>
+            <a:endParaRPr lang="en-US" sz="1200" dirty="0"/>
+          </a:p>
+        </p:txBody>
+      </p:sp>
+    </p:spTree>
+  </p:cSld>
+  <p:clrMapOvr>
+    <a:masterClrMapping/>
+  </p:clrMapOvr>
+</p:sld>
+</file>
+
+<file path=ppt/slides/slide16.xml><?xml version="1.0" encoding="utf-8"?>
+<p:sld xmlns:a="http://schemas.openxmlformats.org/drawingml/2006/main" xmlns:r="http://schemas.openxmlformats.org/officeDocument/2006/relationships" xmlns:p="http://schemas.openxmlformats.org/presentationml/2006/main">
+  <p:cSld name="Slide 16">
+    <p:spTree>
+      <p:nvGrpSpPr>
+        <p:cNvPr id="1" name=""/>
+        <p:cNvGrpSpPr/>
+        <p:nvPr/>
+      </p:nvGrpSpPr>
+      <p:grpSpPr>
+        <a:xfrm>
+          <a:off x="0" y="0"/>
+          <a:ext cx="0" cy="0"/>
+          <a:chOff x="0" y="0"/>
+          <a:chExt cx="0" cy="0"/>
+        </a:xfrm>
+      </p:grpSpPr>
+      <p:sp>
+        <p:nvSpPr>
+          <p:cNvPr id="2" name="Text 0"/>
+          <p:cNvSpPr/>
+          <p:nvPr/>
+        </p:nvSpPr>
+        <p:spPr>
+          <a:xfrm>
+            <a:off x="548640" y="274320"/>
+            <a:ext cx="8046720" cy="777240"/>
+          </a:xfrm>
+          <a:prstGeom prst="rect">
+            <a:avLst/>
+          </a:prstGeom>
+          <a:noFill/>
+          <a:ln/>
+        </p:spPr>
+        <p:txBody>
+          <a:bodyPr wrap="square" lIns="0" tIns="0" rIns="0" bIns="0" rtlCol="0" anchor="ctr"/>
+          <a:lstStyle/>
+          <a:p>
+            <a:pPr indent="0" marL="0">
+              <a:buNone/>
+            </a:pPr>
+            <a:r>
+              <a:rPr lang="en-US" sz="3600" b="1" dirty="0">
+                <a:solidFill>
+                  <a:srgbClr val="111111"/>
+                </a:solidFill>
+                <a:latin typeface="Noto Sans CJK KR" pitchFamily="34" charset="0"/>
+                <a:ea typeface="Noto Sans CJK KR" pitchFamily="34" charset="-122"/>
+                <a:cs typeface="Noto Sans CJK KR" pitchFamily="34" charset="-120"/>
+              </a:rPr>
+              <a:t>Slave의 고장 처리</a:t>
+            </a:r>
+            <a:endParaRPr lang="en-US" sz="3600" dirty="0"/>
+          </a:p>
+        </p:txBody>
+      </p:sp>
+      <p:sp>
+        <p:nvSpPr>
+          <p:cNvPr id="3" name="Text 1"/>
+          <p:cNvSpPr/>
+          <p:nvPr/>
+        </p:nvSpPr>
+        <p:spPr>
+          <a:xfrm>
+            <a:off x="548640" y="1234440"/>
+            <a:ext cx="8046720" cy="2971800"/>
+          </a:xfrm>
+          <a:prstGeom prst="rect">
+            <a:avLst/>
+          </a:prstGeom>
+          <a:noFill/>
+          <a:ln/>
+        </p:spPr>
+        <p:txBody>
+          <a:bodyPr wrap="square" rtlCol="0" anchor="t"/>
+          <a:lstStyle/>
+          <a:p>
+            <a:pPr marL="342900" indent="-342900">
+              <a:spcAft>
+                <a:spcPts val="1200"/>
+              </a:spcAft>
+              <a:buSzPct val="100000"/>
+              <a:buChar char="•"/>
+            </a:pPr>
+            <a:r>
+              <a:rPr lang="en-US" sz="2000" dirty="0">
+                <a:solidFill>
+                  <a:srgbClr val="222222"/>
+                </a:solidFill>
+                <a:latin typeface="Noto Sans CJK KR" pitchFamily="34" charset="0"/>
+                <a:ea typeface="Noto Sans CJK KR" pitchFamily="34" charset="-122"/>
+                <a:cs typeface="Noto Sans CJK KR" pitchFamily="34" charset="-120"/>
+              </a:rPr>
+              <a:t>Master broadcast 프레임의 halt_cmd(halt_mask) 필드를 수신하면 해당 슬롯은 송신 중단</a:t>
+            </a:r>
+            <a:endParaRPr lang="en-US" sz="2000" dirty="0"/>
+          </a:p>
+          <a:p>
+            <a:pPr marL="342900" indent="-342900">
+              <a:spcAft>
+                <a:spcPts val="1200"/>
+              </a:spcAft>
+              <a:buSzPct val="100000"/>
+              <a:buChar char="•"/>
+            </a:pPr>
+            <a:r>
+              <a:rPr lang="en-US" sz="2000" dirty="0">
+                <a:solidFill>
+                  <a:srgbClr val="222222"/>
+                </a:solidFill>
+                <a:latin typeface="Noto Sans CJK KR" pitchFamily="34" charset="0"/>
+                <a:ea typeface="Noto Sans CJK KR" pitchFamily="34" charset="-122"/>
+                <a:cs typeface="Noto Sans CJK KR" pitchFamily="34" charset="-120"/>
+              </a:rPr>
+              <a:t>Master가 다음 broadcast에서 해당 비트를 0으로 보내면 다음 사이클부터 자동으로 재개</a:t>
+            </a:r>
+            <a:endParaRPr lang="en-US" sz="2000" dirty="0"/>
+          </a:p>
+          <a:p>
+            <a:pPr marL="342900" indent="-342900">
+              <a:spcAft>
+                <a:spcPts val="1200"/>
+              </a:spcAft>
+              <a:buSzPct val="100000"/>
+              <a:buChar char="•"/>
+            </a:pPr>
+            <a:r>
+              <a:rPr lang="en-US" sz="2000" dirty="0">
+                <a:solidFill>
+                  <a:srgbClr val="222222"/>
+                </a:solidFill>
+                <a:latin typeface="Noto Sans CJK KR" pitchFamily="34" charset="0"/>
+                <a:ea typeface="Noto Sans CJK KR" pitchFamily="34" charset="-122"/>
+                <a:cs typeface="Noto Sans CJK KR" pitchFamily="34" charset="-120"/>
+              </a:rPr>
+              <a:t>Slave 자체 감지 고장(tx_overlap, slot_timing_invalid, pl_payload6/7_invalid, rx_ham_2bit)은 플래그로 누적되어 인터럽트 신호만 발생, 별도 조치는 없음</a:t>
+            </a:r>
+            <a:endParaRPr lang="en-US" sz="2000" dirty="0"/>
+          </a:p>
+        </p:txBody>
+      </p:sp>
+      <p:sp>
+        <p:nvSpPr>
+          <p:cNvPr id="4" name="Text 2"/>
+          <p:cNvSpPr/>
+          <p:nvPr/>
+        </p:nvSpPr>
+        <p:spPr>
+          <a:xfrm>
+            <a:off x="8503920" y="4754880"/>
+            <a:ext cx="457200" cy="274320"/>
+          </a:xfrm>
+          <a:prstGeom prst="rect">
+            <a:avLst/>
+          </a:prstGeom>
+          <a:noFill/>
+          <a:ln/>
+        </p:spPr>
+        <p:txBody>
+          <a:bodyPr wrap="square" rtlCol="0" anchor="ctr"/>
+          <a:lstStyle/>
+          <a:p>
+            <a:pPr algn="r" indent="0" marL="0">
+              <a:buNone/>
+            </a:pPr>
+            <a:r>
+              <a:rPr lang="en-US" sz="1200" dirty="0">
+                <a:solidFill>
+                  <a:srgbClr val="999999"/>
+                </a:solidFill>
+                <a:latin typeface="Noto Sans CJK KR" pitchFamily="34" charset="0"/>
+                <a:ea typeface="Noto Sans CJK KR" pitchFamily="34" charset="-122"/>
+                <a:cs typeface="Noto Sans CJK KR" pitchFamily="34" charset="-120"/>
+              </a:rPr>
+              <a:t>16</a:t>
+            </a:r>
+            <a:endParaRPr lang="en-US" sz="1200" dirty="0"/>
+          </a:p>
+        </p:txBody>
+      </p:sp>
+    </p:spTree>
+  </p:cSld>
+  <p:clrMapOvr>
+    <a:masterClrMapping/>
+  </p:clrMapOvr>
+</p:sld>
+</file>
+
 <file path=ppt/slides/slide2.xml><?xml version="1.0" encoding="utf-8"?>
 <p:sld xmlns:a="http://schemas.openxmlformats.org/drawingml/2006/main" xmlns:r="http://schemas.openxmlformats.org/officeDocument/2006/relationships" xmlns:p="http://schemas.openxmlformats.org/presentationml/2006/main">
   <p:cSld name="Slide 2">

</xml_diff>

<commit_message>
Rename section 3 title slide to reflect merged scope
Update from "블록도" to "구현 사항" since the section now covers
both block diagrams and implementation/design specifics.

Co-Authored-By: Claude Sonnet 4.6 <noreply@anthropic.com>
Claude-Session: https://claude.ai/code/session_01UcZX9gdfC56CAidpRSm7mN
</commit_message>
<xml_diff>
--- a/section3_block_diagrams.pptx
+++ b/section3_block_diagrams.pptx
@@ -2243,7 +2243,7 @@
                 <a:ea typeface="Noto Sans CJK KR" pitchFamily="34" charset="-122"/>
                 <a:cs typeface="Noto Sans CJK KR" pitchFamily="34" charset="-120"/>
               </a:rPr>
-              <a:t>3. Master / Slave 블록도</a:t>
+              <a:t>3. Master / Slave 구현 사항</a:t>
             </a:r>
             <a:endParaRPr lang="en-US" sz="4000" dirty="0"/>
           </a:p>
@@ -2282,7 +2282,7 @@
                 <a:ea typeface="Noto Sans CJK KR" pitchFamily="34" charset="-122"/>
                 <a:cs typeface="Noto Sans CJK KR" pitchFamily="34" charset="-120"/>
               </a:rPr>
-              <a:t>보드 내부 구조를 단계적으로 확대해서 살펴본다</a:t>
+              <a:t>시스템의 구현과 설계 특이사항을 다룬다</a:t>
             </a:r>
             <a:endParaRPr lang="en-US" sz="2000" dirty="0"/>
           </a:p>

</xml_diff>